<commit_message>
refactor: 💡 pdf changes
</commit_message>
<xml_diff>
--- a/docs/ReadLab-prezentacja.pptx
+++ b/docs/ReadLab-prezentacja.pptx
@@ -4,6 +4,9 @@
   <p:sldMasterIdLst>
     <p:sldMasterId id="2147483648" r:id="rId1"/>
   </p:sldMasterIdLst>
+  <p:notesMasterIdLst>
+    <p:notesMasterId r:id="rId12"/>
+  </p:notesMasterIdLst>
   <p:sldIdLst>
     <p:sldId id="256" r:id="rId2"/>
     <p:sldId id="257" r:id="rId3"/>
@@ -16,9 +19,6 @@
     <p:sldId id="264" r:id="rId10"/>
     <p:sldId id="265" r:id="rId11"/>
   </p:sldIdLst>
-  <p:notesMasterIdLst>
-    <p:notesMasterId r:id="rId12"/>
-  </p:notesMasterIdLst>
   <p:sldSz cx="12192000" cy="6858000"/>
   <p:notesSz cx="6858000" cy="12192000"/>
   <p:defaultTextStyle>
@@ -113,6 +113,11 @@
       </a:defRPr>
     </a:lvl9pPr>
   </p:defaultTextStyle>
+  <p:extLst>
+    <p:ext uri="{EFAFB233-063F-42B5-8137-9DF3F51BA10A}">
+      <p15:sldGuideLst xmlns:p15="http://schemas.microsoft.com/office/powerpoint/2012/main"/>
+    </p:ext>
+  </p:extLst>
 </p:presentation>
 </file>
 
@@ -138,234 +143,10 @@
           <a:chExt cx="0" cy="0"/>
         </a:xfrm>
       </p:grpSpPr>
-      <p:sp>
-        <p:nvSpPr>
-          <p:cNvPr id="2" name="Header Placeholder 1"/>
-          <p:cNvSpPr>
-            <a:spLocks noGrp="1"/>
-          </p:cNvSpPr>
-          <p:nvPr>
-            <p:ph type="hdr" sz="quarter"/>
-          </p:nvPr>
-        </p:nvSpPr>
-        <p:spPr>
-          <a:xfrm>
-            <a:off x="0" y="0"/>
-            <a:ext cx="2971800" cy="458788"/>
-          </a:xfrm>
-          <a:prstGeom prst="rect">
-            <a:avLst/>
-          </a:prstGeom>
-        </p:spPr>
-        <p:txBody>
-          <a:bodyPr vert="horz" lIns="91440" tIns="45720" rIns="91440" bIns="45720" rtlCol="0"/>
-          <a:lstStyle>
-            <a:lvl1pPr algn="l">
-              <a:defRPr sz="1200"/>
-            </a:lvl1pPr>
-          </a:lstStyle>
-          <a:p>
-            <a:endParaRPr lang="en-US"/>
-          </a:p>
-        </p:txBody>
-      </p:sp>
-      <p:sp>
-        <p:nvSpPr>
-          <p:cNvPr id="3" name="Date Placeholder 2"/>
-          <p:cNvSpPr>
-            <a:spLocks noGrp="1"/>
-          </p:cNvSpPr>
-          <p:nvPr>
-            <p:ph type="dt" idx="1"/>
-          </p:nvPr>
-        </p:nvSpPr>
-        <p:spPr>
-          <a:xfrm>
-            <a:off x="3884613" y="0"/>
-            <a:ext cx="2971800" cy="458788"/>
-          </a:xfrm>
-          <a:prstGeom prst="rect">
-            <a:avLst/>
-          </a:prstGeom>
-        </p:spPr>
-        <p:txBody>
-          <a:bodyPr vert="horz" lIns="91440" tIns="45720" rIns="91440" bIns="45720" rtlCol="0"/>
-          <a:lstStyle>
-            <a:lvl1pPr algn="r">
-              <a:defRPr sz="1200"/>
-            </a:lvl1pPr>
-          </a:lstStyle>
-          <a:p>
-            <a:fld id="{5282F153-3F37-0F45-9E97-73ACFA13230C}" type="datetimeFigureOut">
-              <a:rPr lang="en-US"/>
-              <a:t>7/23/19</a:t>
-            </a:fld>
-            <a:endParaRPr lang="en-US"/>
-          </a:p>
-        </p:txBody>
-      </p:sp>
-      <p:sp>
-        <p:nvSpPr>
-          <p:cNvPr id="4" name="Slide Image Placeholder 3"/>
-          <p:cNvSpPr>
-            <a:spLocks noGrp="1" noRot="1" noChangeAspect="1"/>
-          </p:cNvSpPr>
-          <p:nvPr>
-            <p:ph type="sldImg" idx="2"/>
-          </p:nvPr>
-        </p:nvSpPr>
-        <p:spPr>
-          <a:xfrm>
-            <a:off x="685800" y="1143000"/>
-            <a:ext cx="5486400" cy="3086100"/>
-          </a:xfrm>
-          <a:prstGeom prst="rect">
-            <a:avLst/>
-          </a:prstGeom>
-          <a:noFill/>
-          <a:ln w="12700">
-            <a:solidFill>
-              <a:prstClr val="black"/>
-            </a:solidFill>
-          </a:ln>
-        </p:spPr>
-        <p:txBody>
-          <a:bodyPr vert="horz" lIns="91440" tIns="45720" rIns="91440" bIns="45720" rtlCol="0" anchor="ctr"/>
-          <a:lstStyle/>
-          <a:p>
-            <a:endParaRPr lang="en-US"/>
-          </a:p>
-        </p:txBody>
-      </p:sp>
-      <p:sp>
-        <p:nvSpPr>
-          <p:cNvPr id="5" name="Notes Placeholder 4"/>
-          <p:cNvSpPr>
-            <a:spLocks noGrp="1"/>
-          </p:cNvSpPr>
-          <p:nvPr>
-            <p:ph type="body" sz="quarter" idx="3"/>
-          </p:nvPr>
-        </p:nvSpPr>
-        <p:spPr>
-          <a:xfrm>
-            <a:off x="685800" y="4400550"/>
-            <a:ext cx="5486400" cy="3600450"/>
-          </a:xfrm>
-          <a:prstGeom prst="rect">
-            <a:avLst/>
-          </a:prstGeom>
-        </p:spPr>
-        <p:txBody>
-          <a:bodyPr vert="horz" lIns="91440" tIns="45720" rIns="91440" bIns="45720" rtlCol="0"/>
-          <a:lstStyle/>
-          <a:p>
-            <a:pPr lvl="0"/>
-            <a:r>
-              <a:rPr lang="en-US"/>
-              <a:t>Click to edit Master text styles</a:t>
-            </a:r>
-          </a:p>
-          <a:p>
-            <a:pPr lvl="1"/>
-            <a:r>
-              <a:rPr lang="en-US"/>
-              <a:t>Second level</a:t>
-            </a:r>
-          </a:p>
-          <a:p>
-            <a:pPr lvl="2"/>
-            <a:r>
-              <a:rPr lang="en-US"/>
-              <a:t>Third level</a:t>
-            </a:r>
-          </a:p>
-          <a:p>
-            <a:pPr lvl="3"/>
-            <a:r>
-              <a:rPr lang="en-US"/>
-              <a:t>Fourth level</a:t>
-            </a:r>
-          </a:p>
-          <a:p>
-            <a:pPr lvl="4"/>
-            <a:r>
-              <a:rPr lang="en-US"/>
-              <a:t>Fifth level</a:t>
-            </a:r>
-          </a:p>
-        </p:txBody>
-      </p:sp>
-      <p:sp>
-        <p:nvSpPr>
-          <p:cNvPr id="6" name="Footer Placeholder 5"/>
-          <p:cNvSpPr>
-            <a:spLocks noGrp="1"/>
-          </p:cNvSpPr>
-          <p:nvPr>
-            <p:ph type="ftr" sz="quarter" idx="4"/>
-          </p:nvPr>
-        </p:nvSpPr>
-        <p:spPr>
-          <a:xfrm>
-            <a:off x="0" y="8685213"/>
-            <a:ext cx="2971800" cy="458787"/>
-          </a:xfrm>
-          <a:prstGeom prst="rect">
-            <a:avLst/>
-          </a:prstGeom>
-        </p:spPr>
-        <p:txBody>
-          <a:bodyPr vert="horz" lIns="91440" tIns="45720" rIns="91440" bIns="45720" rtlCol="0" anchor="b"/>
-          <a:lstStyle>
-            <a:lvl1pPr algn="l">
-              <a:defRPr sz="1200"/>
-            </a:lvl1pPr>
-          </a:lstStyle>
-          <a:p>
-            <a:endParaRPr lang="en-US"/>
-          </a:p>
-        </p:txBody>
-      </p:sp>
-      <p:sp>
-        <p:nvSpPr>
-          <p:cNvPr id="7" name="Slide Number Placeholder 6"/>
-          <p:cNvSpPr>
-            <a:spLocks noGrp="1"/>
-          </p:cNvSpPr>
-          <p:nvPr>
-            <p:ph type="sldNum" sz="quarter" idx="5"/>
-          </p:nvPr>
-        </p:nvSpPr>
-        <p:spPr>
-          <a:xfrm>
-            <a:off x="3884613" y="8685213"/>
-            <a:ext cx="2971800" cy="458787"/>
-          </a:xfrm>
-          <a:prstGeom prst="rect">
-            <a:avLst/>
-          </a:prstGeom>
-        </p:spPr>
-        <p:txBody>
-          <a:bodyPr vert="horz" lIns="91440" tIns="45720" rIns="91440" bIns="45720" rtlCol="0" anchor="b"/>
-          <a:lstStyle>
-            <a:lvl1pPr algn="r">
-              <a:defRPr sz="1200"/>
-            </a:lvl1pPr>
-          </a:lstStyle>
-          <a:p>
-            <a:fld id="{CE5E9CC1-C706-0F49-92D6-E571CC5EEA8F}" type="slidenum">
-              <a:rPr lang="en-US"/>
-              <a:t>‹#›</a:t>
-            </a:fld>
-            <a:endParaRPr lang="en-US"/>
-          </a:p>
-        </p:txBody>
-      </p:sp>
     </p:spTree>
     <p:extLst>
       <p:ext uri="{BB962C8B-B14F-4D97-AF65-F5344CB8AC3E}">
-        <p14:creationId xmlns:p14="http://schemas.microsoft.com/office/powerpoint/2010/main" val="1024086991"/>
+        <p14:creationId xmlns:p14="http://schemas.microsoft.com/office/powerpoint/2010/main" val="1448094447"/>
       </p:ext>
     </p:extLst>
   </p:cSld>
@@ -509,10 +290,6 @@
           <a:bodyPr/>
           <a:lstStyle/>
           <a:p>
-            <a:r>
-              <a:rPr lang="en-US" dirty="0"/>
-              <a:t/>
-            </a:r>
             <a:endParaRPr lang="en-US" dirty="0"/>
           </a:p>
         </p:txBody>
@@ -597,10 +374,6 @@
           <a:bodyPr/>
           <a:lstStyle/>
           <a:p>
-            <a:r>
-              <a:rPr lang="en-US" dirty="0"/>
-              <a:t/>
-            </a:r>
             <a:endParaRPr lang="en-US" dirty="0"/>
           </a:p>
         </p:txBody>
@@ -685,10 +458,6 @@
           <a:bodyPr/>
           <a:lstStyle/>
           <a:p>
-            <a:r>
-              <a:rPr lang="en-US" dirty="0"/>
-              <a:t/>
-            </a:r>
             <a:endParaRPr lang="en-US" dirty="0"/>
           </a:p>
         </p:txBody>
@@ -773,10 +542,6 @@
           <a:bodyPr/>
           <a:lstStyle/>
           <a:p>
-            <a:r>
-              <a:rPr lang="en-US" dirty="0"/>
-              <a:t/>
-            </a:r>
             <a:endParaRPr lang="en-US" dirty="0"/>
           </a:p>
         </p:txBody>
@@ -861,10 +626,6 @@
           <a:bodyPr/>
           <a:lstStyle/>
           <a:p>
-            <a:r>
-              <a:rPr lang="en-US" dirty="0"/>
-              <a:t/>
-            </a:r>
             <a:endParaRPr lang="en-US" dirty="0"/>
           </a:p>
         </p:txBody>
@@ -949,10 +710,6 @@
           <a:bodyPr/>
           <a:lstStyle/>
           <a:p>
-            <a:r>
-              <a:rPr lang="en-US" dirty="0"/>
-              <a:t/>
-            </a:r>
             <a:endParaRPr lang="en-US" dirty="0"/>
           </a:p>
         </p:txBody>
@@ -1037,10 +794,6 @@
           <a:bodyPr/>
           <a:lstStyle/>
           <a:p>
-            <a:r>
-              <a:rPr lang="en-US" dirty="0"/>
-              <a:t/>
-            </a:r>
             <a:endParaRPr lang="en-US" dirty="0"/>
           </a:p>
         </p:txBody>
@@ -1125,10 +878,6 @@
           <a:bodyPr/>
           <a:lstStyle/>
           <a:p>
-            <a:r>
-              <a:rPr lang="en-US" dirty="0"/>
-              <a:t/>
-            </a:r>
             <a:endParaRPr lang="en-US" dirty="0"/>
           </a:p>
         </p:txBody>
@@ -1213,10 +962,6 @@
           <a:bodyPr/>
           <a:lstStyle/>
           <a:p>
-            <a:r>
-              <a:rPr lang="en-US" dirty="0"/>
-              <a:t/>
-            </a:r>
             <a:endParaRPr lang="en-US" dirty="0"/>
           </a:p>
         </p:txBody>
@@ -1301,10 +1046,6 @@
           <a:bodyPr/>
           <a:lstStyle/>
           <a:p>
-            <a:r>
-              <a:rPr lang="en-US" dirty="0"/>
-              <a:t/>
-            </a:r>
             <a:endParaRPr lang="en-US" dirty="0"/>
           </a:p>
         </p:txBody>
@@ -1378,6 +1119,11 @@
 <file path=ppt/slideMasters/slideMaster1.xml><?xml version="1.0" encoding="utf-8"?>
 <p:sldMaster xmlns:a="http://schemas.openxmlformats.org/drawingml/2006/main" xmlns:r="http://schemas.openxmlformats.org/officeDocument/2006/relationships" xmlns:p="http://schemas.openxmlformats.org/presentationml/2006/main">
   <p:cSld>
+    <p:bg>
+      <p:bgRef idx="1001">
+        <a:schemeClr val="bg1"/>
+      </p:bgRef>
+    </p:bg>
     <p:spTree>
       <p:nvGrpSpPr>
         <p:cNvPr id="1" name=""/>
@@ -1660,6 +1406,7 @@
         <a:solidFill>
           <a:srgbClr val="1D1D1F"/>
         </a:solidFill>
+        <a:effectLst/>
       </p:bgPr>
     </p:bg>
     <p:spTree>
@@ -1702,6 +1449,13 @@
             <a:prstDash val="solid"/>
           </a:ln>
         </p:spPr>
+        <p:txBody>
+          <a:bodyPr/>
+          <a:lstStyle/>
+          <a:p>
+            <a:endParaRPr lang="pl-PL"/>
+          </a:p>
+        </p:txBody>
       </p:sp>
       <p:sp>
         <p:nvSpPr>
@@ -1729,6 +1483,13 @@
             <a:prstDash val="solid"/>
           </a:ln>
         </p:spPr>
+        <p:txBody>
+          <a:bodyPr/>
+          <a:lstStyle/>
+          <a:p>
+            <a:endParaRPr lang="pl-PL"/>
+          </a:p>
+        </p:txBody>
       </p:sp>
       <p:sp>
         <p:nvSpPr>
@@ -1756,6 +1517,13 @@
             <a:prstDash val="solid"/>
           </a:ln>
         </p:spPr>
+        <p:txBody>
+          <a:bodyPr/>
+          <a:lstStyle/>
+          <a:p>
+            <a:endParaRPr lang="pl-PL"/>
+          </a:p>
+        </p:txBody>
       </p:sp>
       <p:sp>
         <p:nvSpPr>
@@ -1783,6 +1551,13 @@
             <a:prstDash val="solid"/>
           </a:ln>
         </p:spPr>
+        <p:txBody>
+          <a:bodyPr/>
+          <a:lstStyle/>
+          <a:p>
+            <a:endParaRPr lang="pl-PL"/>
+          </a:p>
+        </p:txBody>
       </p:sp>
       <p:sp>
         <p:nvSpPr>
@@ -1810,6 +1585,13 @@
             <a:prstDash val="solid"/>
           </a:ln>
         </p:spPr>
+        <p:txBody>
+          <a:bodyPr/>
+          <a:lstStyle/>
+          <a:p>
+            <a:endParaRPr lang="pl-PL"/>
+          </a:p>
+        </p:txBody>
       </p:sp>
       <p:sp>
         <p:nvSpPr>
@@ -1837,6 +1619,13 @@
             <a:prstDash val="solid"/>
           </a:ln>
         </p:spPr>
+        <p:txBody>
+          <a:bodyPr/>
+          <a:lstStyle/>
+          <a:p>
+            <a:endParaRPr lang="pl-PL"/>
+          </a:p>
+        </p:txBody>
       </p:sp>
       <p:sp>
         <p:nvSpPr>
@@ -1864,6 +1653,13 @@
             <a:prstDash val="solid"/>
           </a:ln>
         </p:spPr>
+        <p:txBody>
+          <a:bodyPr/>
+          <a:lstStyle/>
+          <a:p>
+            <a:endParaRPr lang="pl-PL"/>
+          </a:p>
+        </p:txBody>
       </p:sp>
       <p:sp>
         <p:nvSpPr>
@@ -1891,6 +1687,13 @@
             <a:prstDash val="solid"/>
           </a:ln>
         </p:spPr>
+        <p:txBody>
+          <a:bodyPr/>
+          <a:lstStyle/>
+          <a:p>
+            <a:endParaRPr lang="pl-PL"/>
+          </a:p>
+        </p:txBody>
       </p:sp>
       <p:sp>
         <p:nvSpPr>
@@ -1918,6 +1721,13 @@
             <a:prstDash val="solid"/>
           </a:ln>
         </p:spPr>
+        <p:txBody>
+          <a:bodyPr/>
+          <a:lstStyle/>
+          <a:p>
+            <a:endParaRPr lang="pl-PL"/>
+          </a:p>
+        </p:txBody>
       </p:sp>
       <p:sp>
         <p:nvSpPr>
@@ -1945,6 +1755,13 @@
             <a:prstDash val="solid"/>
           </a:ln>
         </p:spPr>
+        <p:txBody>
+          <a:bodyPr/>
+          <a:lstStyle/>
+          <a:p>
+            <a:endParaRPr lang="pl-PL"/>
+          </a:p>
+        </p:txBody>
       </p:sp>
       <p:sp>
         <p:nvSpPr>
@@ -1972,6 +1789,13 @@
             <a:prstDash val="solid"/>
           </a:ln>
         </p:spPr>
+        <p:txBody>
+          <a:bodyPr/>
+          <a:lstStyle/>
+          <a:p>
+            <a:endParaRPr lang="pl-PL"/>
+          </a:p>
+        </p:txBody>
       </p:sp>
       <p:sp>
         <p:nvSpPr>
@@ -1999,6 +1823,13 @@
             <a:prstDash val="solid"/>
           </a:ln>
         </p:spPr>
+        <p:txBody>
+          <a:bodyPr/>
+          <a:lstStyle/>
+          <a:p>
+            <a:endParaRPr lang="pl-PL"/>
+          </a:p>
+        </p:txBody>
       </p:sp>
       <p:sp>
         <p:nvSpPr>
@@ -2021,7 +1852,7 @@
           <a:bodyPr wrap="square" lIns="0" tIns="0" rIns="0" bIns="0" rtlCol="0" anchor="ctr"/>
           <a:lstStyle/>
           <a:p>
-            <a:pPr indent="0" marL="0">
+            <a:pPr marL="0" indent="0">
               <a:buNone/>
             </a:pPr>
             <a:r>
@@ -2060,7 +1891,7 @@
           <a:bodyPr wrap="square" lIns="0" tIns="0" rIns="0" bIns="0" rtlCol="0" anchor="ctr"/>
           <a:lstStyle/>
           <a:p>
-            <a:pPr indent="0" marL="0">
+            <a:pPr marL="0" indent="0">
               <a:buNone/>
             </a:pPr>
             <a:r>
@@ -2099,7 +1930,7 @@
           <a:bodyPr wrap="square" lIns="0" tIns="0" rIns="0" bIns="0" rtlCol="0" anchor="ctr"/>
           <a:lstStyle/>
           <a:p>
-            <a:pPr indent="0" marL="0">
+            <a:pPr marL="0" indent="0">
               <a:lnSpc>
                 <a:spcPct val="130000"/>
               </a:lnSpc>
@@ -2119,7 +1950,7 @@
             <a:endParaRPr lang="en-US" sz="1400" dirty="0"/>
           </a:p>
           <a:p>
-            <a:pPr indent="0" marL="0">
+            <a:pPr marL="0" indent="0">
               <a:lnSpc>
                 <a:spcPct val="130000"/>
               </a:lnSpc>
@@ -2161,7 +1992,7 @@
           <a:bodyPr wrap="square" lIns="0" tIns="0" rIns="0" bIns="0" rtlCol="0" anchor="ctr"/>
           <a:lstStyle/>
           <a:p>
-            <a:pPr indent="0" marL="0">
+            <a:pPr marL="0" indent="0">
               <a:buNone/>
             </a:pPr>
             <a:r>
@@ -2195,6 +2026,7 @@
         <a:solidFill>
           <a:srgbClr val="1D1D1F"/>
         </a:solidFill>
+        <a:effectLst/>
       </p:bgPr>
     </p:bg>
     <p:spTree>
@@ -2237,6 +2069,13 @@
             <a:prstDash val="solid"/>
           </a:ln>
         </p:spPr>
+        <p:txBody>
+          <a:bodyPr/>
+          <a:lstStyle/>
+          <a:p>
+            <a:endParaRPr lang="pl-PL"/>
+          </a:p>
+        </p:txBody>
       </p:sp>
       <p:sp>
         <p:nvSpPr>
@@ -2264,6 +2103,13 @@
             <a:prstDash val="solid"/>
           </a:ln>
         </p:spPr>
+        <p:txBody>
+          <a:bodyPr/>
+          <a:lstStyle/>
+          <a:p>
+            <a:endParaRPr lang="pl-PL"/>
+          </a:p>
+        </p:txBody>
       </p:sp>
       <p:sp>
         <p:nvSpPr>
@@ -2291,6 +2137,13 @@
             <a:prstDash val="solid"/>
           </a:ln>
         </p:spPr>
+        <p:txBody>
+          <a:bodyPr/>
+          <a:lstStyle/>
+          <a:p>
+            <a:endParaRPr lang="pl-PL"/>
+          </a:p>
+        </p:txBody>
       </p:sp>
       <p:sp>
         <p:nvSpPr>
@@ -2318,6 +2171,13 @@
             <a:prstDash val="solid"/>
           </a:ln>
         </p:spPr>
+        <p:txBody>
+          <a:bodyPr/>
+          <a:lstStyle/>
+          <a:p>
+            <a:endParaRPr lang="pl-PL"/>
+          </a:p>
+        </p:txBody>
       </p:sp>
       <p:sp>
         <p:nvSpPr>
@@ -2345,6 +2205,13 @@
             <a:prstDash val="solid"/>
           </a:ln>
         </p:spPr>
+        <p:txBody>
+          <a:bodyPr/>
+          <a:lstStyle/>
+          <a:p>
+            <a:endParaRPr lang="pl-PL"/>
+          </a:p>
+        </p:txBody>
       </p:sp>
       <p:sp>
         <p:nvSpPr>
@@ -2372,6 +2239,13 @@
             <a:prstDash val="solid"/>
           </a:ln>
         </p:spPr>
+        <p:txBody>
+          <a:bodyPr/>
+          <a:lstStyle/>
+          <a:p>
+            <a:endParaRPr lang="pl-PL"/>
+          </a:p>
+        </p:txBody>
       </p:sp>
       <p:sp>
         <p:nvSpPr>
@@ -2399,6 +2273,13 @@
             <a:prstDash val="solid"/>
           </a:ln>
         </p:spPr>
+        <p:txBody>
+          <a:bodyPr/>
+          <a:lstStyle/>
+          <a:p>
+            <a:endParaRPr lang="pl-PL"/>
+          </a:p>
+        </p:txBody>
       </p:sp>
       <p:sp>
         <p:nvSpPr>
@@ -2426,6 +2307,13 @@
             <a:prstDash val="solid"/>
           </a:ln>
         </p:spPr>
+        <p:txBody>
+          <a:bodyPr/>
+          <a:lstStyle/>
+          <a:p>
+            <a:endParaRPr lang="pl-PL"/>
+          </a:p>
+        </p:txBody>
       </p:sp>
       <p:sp>
         <p:nvSpPr>
@@ -2453,6 +2341,13 @@
             <a:prstDash val="solid"/>
           </a:ln>
         </p:spPr>
+        <p:txBody>
+          <a:bodyPr/>
+          <a:lstStyle/>
+          <a:p>
+            <a:endParaRPr lang="pl-PL"/>
+          </a:p>
+        </p:txBody>
       </p:sp>
       <p:sp>
         <p:nvSpPr>
@@ -2480,6 +2375,13 @@
             <a:prstDash val="solid"/>
           </a:ln>
         </p:spPr>
+        <p:txBody>
+          <a:bodyPr/>
+          <a:lstStyle/>
+          <a:p>
+            <a:endParaRPr lang="pl-PL"/>
+          </a:p>
+        </p:txBody>
       </p:sp>
       <p:sp>
         <p:nvSpPr>
@@ -2507,6 +2409,13 @@
             <a:prstDash val="solid"/>
           </a:ln>
         </p:spPr>
+        <p:txBody>
+          <a:bodyPr/>
+          <a:lstStyle/>
+          <a:p>
+            <a:endParaRPr lang="pl-PL"/>
+          </a:p>
+        </p:txBody>
       </p:sp>
       <p:sp>
         <p:nvSpPr>
@@ -2534,6 +2443,13 @@
             <a:prstDash val="solid"/>
           </a:ln>
         </p:spPr>
+        <p:txBody>
+          <a:bodyPr/>
+          <a:lstStyle/>
+          <a:p>
+            <a:endParaRPr lang="pl-PL"/>
+          </a:p>
+        </p:txBody>
       </p:sp>
       <p:sp>
         <p:nvSpPr>
@@ -2556,7 +2472,7 @@
           <a:bodyPr wrap="square" lIns="0" tIns="0" rIns="0" bIns="0" rtlCol="0" anchor="ctr"/>
           <a:lstStyle/>
           <a:p>
-            <a:pPr indent="0" marL="0">
+            <a:pPr marL="0" indent="0">
               <a:buNone/>
             </a:pPr>
             <a:r>
@@ -2595,7 +2511,7 @@
           <a:bodyPr wrap="square" lIns="0" tIns="0" rIns="0" bIns="0" rtlCol="0" anchor="ctr"/>
           <a:lstStyle/>
           <a:p>
-            <a:pPr indent="0" marL="0">
+            <a:pPr marL="0" indent="0">
               <a:buNone/>
             </a:pPr>
             <a:r>
@@ -2634,7 +2550,7 @@
           <a:bodyPr wrap="square" lIns="0" tIns="0" rIns="0" bIns="0" rtlCol="0" anchor="ctr"/>
           <a:lstStyle/>
           <a:p>
-            <a:pPr indent="0" marL="0">
+            <a:pPr marL="0" indent="0">
               <a:lnSpc>
                 <a:spcPct val="140000"/>
               </a:lnSpc>
@@ -2651,14 +2567,28 @@
               </a:rPr>
               <a:t>Repozytorium:  </a:t>
             </a:r>
-            <a:pPr indent="0" marL="0">
+            <a:r>
+              <a:rPr lang="en-US" sz="1400" dirty="0">
+                <a:solidFill>
+                  <a:srgbClr val="AEAEB2"/>
+                </a:solidFill>
+                <a:latin typeface="Helvetica Neue" pitchFamily="34" charset="0"/>
+                <a:ea typeface="Helvetica Neue" pitchFamily="34" charset="-122"/>
+                <a:cs typeface="Helvetica Neue" pitchFamily="34" charset="-120"/>
+              </a:rPr>
+              <a:t>github.com/neumann1337/readlab</a:t>
+            </a:r>
+            <a:endParaRPr lang="en-US" sz="1400" dirty="0"/>
+          </a:p>
+          <a:p>
+            <a:pPr marL="0" indent="0">
               <a:lnSpc>
                 <a:spcPct val="140000"/>
               </a:lnSpc>
               <a:buNone/>
             </a:pPr>
             <a:r>
-              <a:rPr lang="en-US" sz="1400" dirty="0">
+              <a:rPr lang="en-US" sz="1400" b="1" dirty="0">
                 <a:solidFill>
                   <a:srgbClr val="AEAEB2"/>
                 </a:solidFill>
@@ -2666,34 +2596,8 @@
                 <a:ea typeface="Helvetica Neue" pitchFamily="34" charset="-122"/>
                 <a:cs typeface="Helvetica Neue" pitchFamily="34" charset="-120"/>
               </a:rPr>
-              <a:t>github.com/neumann1337/readlab</a:t>
-            </a:r>
-            <a:endParaRPr lang="en-US" sz="1400" dirty="0"/>
-          </a:p>
-          <a:p>
-            <a:pPr indent="0" marL="0">
-              <a:lnSpc>
-                <a:spcPct val="140000"/>
-              </a:lnSpc>
-              <a:buNone/>
-            </a:pPr>
-            <a:r>
-              <a:rPr lang="en-US" sz="1400" b="1" dirty="0">
-                <a:solidFill>
-                  <a:srgbClr val="AEAEB2"/>
-                </a:solidFill>
-                <a:latin typeface="Helvetica Neue" pitchFamily="34" charset="0"/>
-                <a:ea typeface="Helvetica Neue" pitchFamily="34" charset="-122"/>
-                <a:cs typeface="Helvetica Neue" pitchFamily="34" charset="-120"/>
-              </a:rPr>
               <a:t>Prototyp Figma:  </a:t>
             </a:r>
-            <a:pPr indent="0" marL="0">
-              <a:lnSpc>
-                <a:spcPct val="140000"/>
-              </a:lnSpc>
-              <a:buNone/>
-            </a:pPr>
             <a:r>
               <a:rPr lang="en-US" sz="1400" dirty="0">
                 <a:solidFill>
@@ -2725,6 +2629,7 @@
         <a:solidFill>
           <a:srgbClr val="F5F5F7"/>
         </a:solidFill>
+        <a:effectLst/>
       </p:bgPr>
     </p:bg>
     <p:spTree>
@@ -2762,11 +2667,11 @@
           <a:bodyPr wrap="square" lIns="0" tIns="0" rIns="0" bIns="0" rtlCol="0" anchor="ctr"/>
           <a:lstStyle/>
           <a:p>
-            <a:pPr indent="0" marL="0">
+            <a:pPr marL="0" indent="0">
               <a:buNone/>
             </a:pPr>
             <a:r>
-              <a:rPr lang="en-US" sz="1300" b="1" spc="300" kern="0" dirty="0">
+              <a:rPr lang="en-US" sz="1300" b="1" kern="0" spc="300" dirty="0">
                 <a:solidFill>
                   <a:srgbClr val="6E6E73"/>
                 </a:solidFill>
@@ -2801,7 +2706,7 @@
           <a:bodyPr wrap="square" lIns="0" tIns="0" rIns="0" bIns="0" rtlCol="0" anchor="ctr"/>
           <a:lstStyle/>
           <a:p>
-            <a:pPr indent="0" marL="0">
+            <a:pPr marL="0" indent="0">
               <a:lnSpc>
                 <a:spcPct val="100000"/>
               </a:lnSpc>
@@ -2843,7 +2748,7 @@
           <a:bodyPr wrap="square" lIns="0" tIns="0" rIns="0" bIns="0" rtlCol="0" anchor="ctr"/>
           <a:lstStyle/>
           <a:p>
-            <a:pPr indent="0" marL="0">
+            <a:pPr marL="0" indent="0">
               <a:lnSpc>
                 <a:spcPct val="130000"/>
               </a:lnSpc>
@@ -2970,7 +2875,7 @@
           <a:bodyPr wrap="square" lIns="0" tIns="0" rIns="0" bIns="0" rtlCol="0" anchor="ctr"/>
           <a:lstStyle/>
           <a:p>
-            <a:pPr indent="0" marL="0">
+            <a:pPr marL="0" indent="0">
               <a:lnSpc>
                 <a:spcPct val="125000"/>
               </a:lnSpc>
@@ -3012,11 +2917,11 @@
           <a:bodyPr wrap="square" lIns="0" tIns="0" rIns="0" bIns="0" rtlCol="0" anchor="ctr"/>
           <a:lstStyle/>
           <a:p>
-            <a:pPr indent="0" marL="0">
+            <a:pPr marL="0" indent="0">
               <a:buNone/>
             </a:pPr>
             <a:r>
-              <a:rPr lang="en-US" sz="900" b="1" spc="100" kern="0" dirty="0">
+              <a:rPr lang="en-US" sz="900" b="1" kern="0" spc="100" dirty="0">
                 <a:solidFill>
                   <a:srgbClr val="6E6E73"/>
                 </a:solidFill>
@@ -3056,13 +2961,20 @@
             <a:prstDash val="solid"/>
           </a:ln>
           <a:effectLst>
-            <a:outerShdw sx="100000" sy="100000" kx="0" ky="0" algn="bl" rotWithShape="0" blurRad="127000" dist="38100" dir="8100000">
+            <a:outerShdw blurRad="127000" dist="38100" dir="8100000" algn="bl" rotWithShape="0">
               <a:srgbClr val="000000">
                 <a:alpha val="10000"/>
               </a:srgbClr>
             </a:outerShdw>
           </a:effectLst>
         </p:spPr>
+        <p:txBody>
+          <a:bodyPr/>
+          <a:lstStyle/>
+          <a:p>
+            <a:endParaRPr lang="pl-PL"/>
+          </a:p>
+        </p:txBody>
       </p:sp>
       <p:sp>
         <p:nvSpPr>
@@ -3090,13 +3002,20 @@
             <a:prstDash val="solid"/>
           </a:ln>
           <a:effectLst>
-            <a:outerShdw sx="100000" sy="100000" kx="0" ky="0" algn="bl" rotWithShape="0" blurRad="127000" dist="38100" dir="8100000">
+            <a:outerShdw blurRad="127000" dist="38100" dir="8100000" algn="bl" rotWithShape="0">
               <a:srgbClr val="000000">
                 <a:alpha val="10000"/>
               </a:srgbClr>
             </a:outerShdw>
           </a:effectLst>
         </p:spPr>
+        <p:txBody>
+          <a:bodyPr/>
+          <a:lstStyle/>
+          <a:p>
+            <a:endParaRPr lang="pl-PL"/>
+          </a:p>
+        </p:txBody>
       </p:sp>
       <p:sp>
         <p:nvSpPr>
@@ -3124,13 +3043,20 @@
             <a:prstDash val="solid"/>
           </a:ln>
           <a:effectLst>
-            <a:outerShdw sx="100000" sy="100000" kx="0" ky="0" algn="bl" rotWithShape="0" blurRad="127000" dist="38100" dir="8100000">
+            <a:outerShdw blurRad="127000" dist="38100" dir="8100000" algn="bl" rotWithShape="0">
               <a:srgbClr val="000000">
                 <a:alpha val="10000"/>
               </a:srgbClr>
             </a:outerShdw>
           </a:effectLst>
         </p:spPr>
+        <p:txBody>
+          <a:bodyPr/>
+          <a:lstStyle/>
+          <a:p>
+            <a:endParaRPr lang="pl-PL"/>
+          </a:p>
+        </p:txBody>
       </p:sp>
       <p:sp>
         <p:nvSpPr>
@@ -3153,11 +3079,11 @@
           <a:bodyPr wrap="square" lIns="0" tIns="0" rIns="0" bIns="0" rtlCol="0" anchor="ctr"/>
           <a:lstStyle/>
           <a:p>
-            <a:pPr indent="0" marL="0">
+            <a:pPr marL="0" indent="0">
               <a:buNone/>
             </a:pPr>
             <a:r>
-              <a:rPr lang="en-US" sz="900" b="1" spc="100" kern="0" dirty="0">
+              <a:rPr lang="en-US" sz="900" b="1" kern="0" spc="100" dirty="0">
                 <a:solidFill>
                   <a:srgbClr val="6E6E73"/>
                 </a:solidFill>
@@ -3197,13 +3123,20 @@
             <a:prstDash val="solid"/>
           </a:ln>
           <a:effectLst>
-            <a:outerShdw sx="100000" sy="100000" kx="0" ky="0" algn="bl" rotWithShape="0" blurRad="127000" dist="38100" dir="8100000">
+            <a:outerShdw blurRad="127000" dist="38100" dir="8100000" algn="bl" rotWithShape="0">
               <a:srgbClr val="000000">
                 <a:alpha val="10000"/>
               </a:srgbClr>
             </a:outerShdw>
           </a:effectLst>
         </p:spPr>
+        <p:txBody>
+          <a:bodyPr/>
+          <a:lstStyle/>
+          <a:p>
+            <a:endParaRPr lang="pl-PL"/>
+          </a:p>
+        </p:txBody>
       </p:sp>
       <p:sp>
         <p:nvSpPr>
@@ -3226,11 +3159,11 @@
           <a:bodyPr wrap="square" lIns="0" tIns="0" rIns="0" bIns="0" rtlCol="0" anchor="ctr"/>
           <a:lstStyle/>
           <a:p>
-            <a:pPr indent="0" marL="0">
+            <a:pPr marL="0" indent="0">
               <a:buNone/>
             </a:pPr>
             <a:r>
-              <a:rPr lang="en-US" sz="900" b="1" spc="100" kern="0" dirty="0">
+              <a:rPr lang="en-US" sz="900" b="1" kern="0" spc="100" dirty="0">
                 <a:solidFill>
                   <a:srgbClr val="6E6E73"/>
                 </a:solidFill>
@@ -3270,13 +3203,20 @@
             <a:prstDash val="solid"/>
           </a:ln>
           <a:effectLst>
-            <a:outerShdw sx="100000" sy="100000" kx="0" ky="0" algn="bl" rotWithShape="0" blurRad="127000" dist="38100" dir="8100000">
+            <a:outerShdw blurRad="127000" dist="38100" dir="8100000" algn="bl" rotWithShape="0">
               <a:srgbClr val="000000">
                 <a:alpha val="10000"/>
               </a:srgbClr>
             </a:outerShdw>
           </a:effectLst>
         </p:spPr>
+        <p:txBody>
+          <a:bodyPr/>
+          <a:lstStyle/>
+          <a:p>
+            <a:endParaRPr lang="pl-PL"/>
+          </a:p>
+        </p:txBody>
       </p:sp>
       <p:sp>
         <p:nvSpPr>
@@ -3299,7 +3239,7 @@
           <a:bodyPr wrap="square" lIns="0" tIns="0" rIns="0" bIns="0" rtlCol="0" anchor="ctr"/>
           <a:lstStyle/>
           <a:p>
-            <a:pPr indent="0" marL="0">
+            <a:pPr marL="0" indent="0">
               <a:buNone/>
             </a:pPr>
             <a:r>
@@ -3338,7 +3278,7 @@
           <a:bodyPr wrap="square" lIns="0" tIns="0" rIns="0" bIns="0" rtlCol="0" anchor="ctr"/>
           <a:lstStyle/>
           <a:p>
-            <a:pPr algn="r" indent="0" marL="0">
+            <a:pPr marL="0" indent="0" algn="r">
               <a:buNone/>
             </a:pPr>
             <a:r>
@@ -3372,6 +3312,7 @@
         <a:solidFill>
           <a:srgbClr val="F5F5F7"/>
         </a:solidFill>
+        <a:effectLst/>
       </p:bgPr>
     </p:bg>
     <p:spTree>
@@ -3409,11 +3350,11 @@
           <a:bodyPr wrap="square" lIns="0" tIns="0" rIns="0" bIns="0" rtlCol="0" anchor="ctr"/>
           <a:lstStyle/>
           <a:p>
-            <a:pPr indent="0" marL="0">
+            <a:pPr marL="0" indent="0">
               <a:buNone/>
             </a:pPr>
             <a:r>
-              <a:rPr lang="en-US" sz="1300" b="1" spc="300" kern="0" dirty="0">
+              <a:rPr lang="en-US" sz="1300" b="1" kern="0" spc="300" dirty="0">
                 <a:solidFill>
                   <a:srgbClr val="6E6E73"/>
                 </a:solidFill>
@@ -3448,7 +3389,7 @@
           <a:bodyPr wrap="square" lIns="0" tIns="0" rIns="0" bIns="0" rtlCol="0" anchor="ctr"/>
           <a:lstStyle/>
           <a:p>
-            <a:pPr indent="0" marL="0">
+            <a:pPr marL="0" indent="0">
               <a:lnSpc>
                 <a:spcPct val="100000"/>
               </a:lnSpc>
@@ -3495,13 +3436,20 @@
             <a:prstDash val="solid"/>
           </a:ln>
           <a:effectLst>
-            <a:outerShdw sx="100000" sy="100000" kx="0" ky="0" algn="bl" rotWithShape="0" blurRad="127000" dist="38100" dir="8100000">
+            <a:outerShdw blurRad="127000" dist="38100" dir="8100000" algn="bl" rotWithShape="0">
               <a:srgbClr val="000000">
                 <a:alpha val="10000"/>
               </a:srgbClr>
             </a:outerShdw>
           </a:effectLst>
         </p:spPr>
+        <p:txBody>
+          <a:bodyPr/>
+          <a:lstStyle/>
+          <a:p>
+            <a:endParaRPr lang="pl-PL"/>
+          </a:p>
+        </p:txBody>
       </p:sp>
       <p:sp>
         <p:nvSpPr>
@@ -3524,7 +3472,7 @@
           <a:bodyPr wrap="square" lIns="0" tIns="0" rIns="0" bIns="0" rtlCol="0" anchor="ctr"/>
           <a:lstStyle/>
           <a:p>
-            <a:pPr indent="0" marL="0">
+            <a:pPr marL="0" indent="0">
               <a:buNone/>
             </a:pPr>
             <a:r>
@@ -3563,7 +3511,7 @@
           <a:bodyPr wrap="square" lIns="0" tIns="0" rIns="0" bIns="0" rtlCol="0" anchor="ctr"/>
           <a:lstStyle/>
           <a:p>
-            <a:pPr indent="0" marL="0">
+            <a:pPr marL="0" indent="0">
               <a:buNone/>
             </a:pPr>
             <a:r>
@@ -3701,13 +3649,20 @@
             <a:prstDash val="solid"/>
           </a:ln>
           <a:effectLst>
-            <a:outerShdw sx="100000" sy="100000" kx="0" ky="0" algn="bl" rotWithShape="0" blurRad="127000" dist="38100" dir="8100000">
+            <a:outerShdw blurRad="127000" dist="38100" dir="8100000" algn="bl" rotWithShape="0">
               <a:srgbClr val="000000">
                 <a:alpha val="10000"/>
               </a:srgbClr>
             </a:outerShdw>
           </a:effectLst>
         </p:spPr>
+        <p:txBody>
+          <a:bodyPr/>
+          <a:lstStyle/>
+          <a:p>
+            <a:endParaRPr lang="pl-PL"/>
+          </a:p>
+        </p:txBody>
       </p:sp>
       <p:sp>
         <p:nvSpPr>
@@ -3730,7 +3685,7 @@
           <a:bodyPr wrap="square" lIns="0" tIns="0" rIns="0" bIns="0" rtlCol="0" anchor="ctr"/>
           <a:lstStyle/>
           <a:p>
-            <a:pPr indent="0" marL="0">
+            <a:pPr marL="0" indent="0">
               <a:buNone/>
             </a:pPr>
             <a:r>
@@ -3769,7 +3724,7 @@
           <a:bodyPr wrap="square" lIns="0" tIns="0" rIns="0" bIns="0" rtlCol="0" anchor="ctr"/>
           <a:lstStyle/>
           <a:p>
-            <a:pPr indent="0" marL="0">
+            <a:pPr marL="0" indent="0">
               <a:buNone/>
             </a:pPr>
             <a:r>
@@ -3851,7 +3806,62 @@
                 <a:ea typeface="Helvetica Neue" pitchFamily="34" charset="-122"/>
                 <a:cs typeface="Helvetica Neue" pitchFamily="34" charset="-120"/>
               </a:rPr>
-              <a:t>Zapomina o terminach, dodaje „na szybko”</a:t>
+              <a:t>Zapomina o terminach, </a:t>
+            </a:r>
+            <a:r>
+              <a:rPr lang="en-US" sz="1400" dirty="0" err="1">
+                <a:solidFill>
+                  <a:srgbClr val="1D1D1F"/>
+                </a:solidFill>
+                <a:latin typeface="Helvetica Neue" pitchFamily="34" charset="0"/>
+                <a:ea typeface="Helvetica Neue" pitchFamily="34" charset="-122"/>
+                <a:cs typeface="Helvetica Neue" pitchFamily="34" charset="-120"/>
+              </a:rPr>
+              <a:t>dodaje</a:t>
+            </a:r>
+            <a:r>
+              <a:rPr lang="en-US" sz="1400" dirty="0">
+                <a:solidFill>
+                  <a:srgbClr val="1D1D1F"/>
+                </a:solidFill>
+                <a:latin typeface="Helvetica Neue" pitchFamily="34" charset="0"/>
+                <a:ea typeface="Helvetica Neue" pitchFamily="34" charset="-122"/>
+                <a:cs typeface="Helvetica Neue" pitchFamily="34" charset="-120"/>
+              </a:rPr>
+              <a:t> </a:t>
+            </a:r>
+            <a:r>
+              <a:rPr lang="en-US" sz="1400" dirty="0" err="1">
+                <a:solidFill>
+                  <a:srgbClr val="1D1D1F"/>
+                </a:solidFill>
+                <a:latin typeface="Helvetica Neue" pitchFamily="34" charset="0"/>
+                <a:ea typeface="Helvetica Neue" pitchFamily="34" charset="-122"/>
+                <a:cs typeface="Helvetica Neue" pitchFamily="34" charset="-120"/>
+              </a:rPr>
+              <a:t>na</a:t>
+            </a:r>
+            <a:r>
+              <a:rPr lang="en-US" sz="1400" dirty="0">
+                <a:solidFill>
+                  <a:srgbClr val="1D1D1F"/>
+                </a:solidFill>
+                <a:latin typeface="Helvetica Neue" pitchFamily="34" charset="0"/>
+                <a:ea typeface="Helvetica Neue" pitchFamily="34" charset="-122"/>
+                <a:cs typeface="Helvetica Neue" pitchFamily="34" charset="-120"/>
+              </a:rPr>
+              <a:t> </a:t>
+            </a:r>
+            <a:r>
+              <a:rPr lang="en-US" sz="1400" dirty="0" err="1">
+                <a:solidFill>
+                  <a:srgbClr val="1D1D1F"/>
+                </a:solidFill>
+                <a:latin typeface="Helvetica Neue" pitchFamily="34" charset="0"/>
+                <a:ea typeface="Helvetica Neue" pitchFamily="34" charset="-122"/>
+                <a:cs typeface="Helvetica Neue" pitchFamily="34" charset="-120"/>
+              </a:rPr>
+              <a:t>szybko</a:t>
             </a:r>
             <a:endParaRPr lang="en-US" sz="1400" dirty="0"/>
           </a:p>
@@ -3902,7 +3912,7 @@
           <a:bodyPr wrap="square" lIns="0" tIns="0" rIns="0" bIns="0" rtlCol="0" anchor="ctr"/>
           <a:lstStyle/>
           <a:p>
-            <a:pPr indent="0" marL="0">
+            <a:pPr marL="0" indent="0">
               <a:buNone/>
             </a:pPr>
             <a:r>
@@ -3941,7 +3951,7 @@
           <a:bodyPr wrap="square" lIns="0" tIns="0" rIns="0" bIns="0" rtlCol="0" anchor="ctr"/>
           <a:lstStyle/>
           <a:p>
-            <a:pPr algn="r" indent="0" marL="0">
+            <a:pPr marL="0" indent="0" algn="r">
               <a:buNone/>
             </a:pPr>
             <a:r>
@@ -3975,6 +3985,7 @@
         <a:solidFill>
           <a:srgbClr val="F5F5F7"/>
         </a:solidFill>
+        <a:effectLst/>
       </p:bgPr>
     </p:bg>
     <p:spTree>
@@ -4012,11 +4023,11 @@
           <a:bodyPr wrap="square" lIns="0" tIns="0" rIns="0" bIns="0" rtlCol="0" anchor="ctr"/>
           <a:lstStyle/>
           <a:p>
-            <a:pPr indent="0" marL="0">
+            <a:pPr marL="0" indent="0">
               <a:buNone/>
             </a:pPr>
             <a:r>
-              <a:rPr lang="en-US" sz="1300" b="1" spc="300" kern="0" dirty="0">
+              <a:rPr lang="en-US" sz="1300" b="1" kern="0" spc="300" dirty="0">
                 <a:solidFill>
                   <a:srgbClr val="6E6E73"/>
                 </a:solidFill>
@@ -4051,7 +4062,7 @@
           <a:bodyPr wrap="square" lIns="0" tIns="0" rIns="0" bIns="0" rtlCol="0" anchor="ctr"/>
           <a:lstStyle/>
           <a:p>
-            <a:pPr indent="0" marL="0">
+            <a:pPr marL="0" indent="0">
               <a:lnSpc>
                 <a:spcPct val="100000"/>
               </a:lnSpc>
@@ -4066,7 +4077,29 @@
                 <a:ea typeface="Helvetica Neue" pitchFamily="34" charset="-122"/>
                 <a:cs typeface="Helvetica Neue" pitchFamily="34" charset="-120"/>
               </a:rPr>
-              <a:t>Pełny proces UX/UI — iteracyjnie</a:t>
+              <a:t>Pełny proces UX/UI </a:t>
+            </a:r>
+            <a:r>
+              <a:rPr lang="pl-PL" sz="3200" b="1" dirty="0">
+                <a:solidFill>
+                  <a:srgbClr val="1D1D1F"/>
+                </a:solidFill>
+                <a:latin typeface="Helvetica Neue" pitchFamily="34" charset="0"/>
+                <a:ea typeface="Helvetica Neue" pitchFamily="34" charset="-122"/>
+                <a:cs typeface="Helvetica Neue" pitchFamily="34" charset="-120"/>
+              </a:rPr>
+              <a:t>-</a:t>
+            </a:r>
+            <a:r>
+              <a:rPr lang="en-US" sz="3200" b="1" dirty="0">
+                <a:solidFill>
+                  <a:srgbClr val="1D1D1F"/>
+                </a:solidFill>
+                <a:latin typeface="Helvetica Neue" pitchFamily="34" charset="0"/>
+                <a:ea typeface="Helvetica Neue" pitchFamily="34" charset="-122"/>
+                <a:cs typeface="Helvetica Neue" pitchFamily="34" charset="-120"/>
+              </a:rPr>
+              <a:t> iteracyjnie</a:t>
             </a:r>
             <a:endParaRPr lang="en-US" sz="3200" dirty="0"/>
           </a:p>
@@ -4098,13 +4131,20 @@
             <a:prstDash val="solid"/>
           </a:ln>
           <a:effectLst>
-            <a:outerShdw sx="100000" sy="100000" kx="0" ky="0" algn="bl" rotWithShape="0" blurRad="127000" dist="38100" dir="8100000">
+            <a:outerShdw blurRad="127000" dist="38100" dir="8100000" algn="bl" rotWithShape="0">
               <a:srgbClr val="000000">
                 <a:alpha val="10000"/>
               </a:srgbClr>
             </a:outerShdw>
           </a:effectLst>
         </p:spPr>
+        <p:txBody>
+          <a:bodyPr/>
+          <a:lstStyle/>
+          <a:p>
+            <a:endParaRPr lang="pl-PL"/>
+          </a:p>
+        </p:txBody>
       </p:sp>
       <p:sp>
         <p:nvSpPr>
@@ -4127,7 +4167,7 @@
           <a:bodyPr wrap="square" lIns="0" tIns="0" rIns="0" bIns="0" rtlCol="0" anchor="ctr"/>
           <a:lstStyle/>
           <a:p>
-            <a:pPr algn="ctr" indent="0" marL="0">
+            <a:pPr marL="0" indent="0" algn="ctr">
               <a:buNone/>
             </a:pPr>
             <a:r>
@@ -4166,7 +4206,7 @@
           <a:bodyPr wrap="square" lIns="0" tIns="0" rIns="0" bIns="0" rtlCol="0" anchor="ctr"/>
           <a:lstStyle/>
           <a:p>
-            <a:pPr algn="ctr" indent="0" marL="0">
+            <a:pPr marL="0" indent="0" algn="ctr">
               <a:lnSpc>
                 <a:spcPct val="105000"/>
               </a:lnSpc>
@@ -4186,7 +4226,7 @@
             <a:endParaRPr lang="en-US" sz="1300" dirty="0"/>
           </a:p>
           <a:p>
-            <a:pPr algn="ctr" indent="0" marL="0">
+            <a:pPr marL="0" indent="0" algn="ctr">
               <a:lnSpc>
                 <a:spcPct val="105000"/>
               </a:lnSpc>
@@ -4228,7 +4268,7 @@
           <a:bodyPr wrap="square" lIns="0" tIns="0" rIns="0" bIns="0" rtlCol="0" anchor="ctr"/>
           <a:lstStyle/>
           <a:p>
-            <a:pPr algn="ctr" indent="0" marL="0">
+            <a:pPr marL="0" indent="0" algn="ctr">
               <a:buNone/>
             </a:pPr>
             <a:r>
@@ -4272,13 +4312,20 @@
             <a:prstDash val="solid"/>
           </a:ln>
           <a:effectLst>
-            <a:outerShdw sx="100000" sy="100000" kx="0" ky="0" algn="bl" rotWithShape="0" blurRad="127000" dist="38100" dir="8100000">
+            <a:outerShdw blurRad="127000" dist="38100" dir="8100000" algn="bl" rotWithShape="0">
               <a:srgbClr val="000000">
                 <a:alpha val="10000"/>
               </a:srgbClr>
             </a:outerShdw>
           </a:effectLst>
         </p:spPr>
+        <p:txBody>
+          <a:bodyPr/>
+          <a:lstStyle/>
+          <a:p>
+            <a:endParaRPr lang="pl-PL"/>
+          </a:p>
+        </p:txBody>
       </p:sp>
       <p:sp>
         <p:nvSpPr>
@@ -4301,7 +4348,7 @@
           <a:bodyPr wrap="square" lIns="0" tIns="0" rIns="0" bIns="0" rtlCol="0" anchor="ctr"/>
           <a:lstStyle/>
           <a:p>
-            <a:pPr algn="ctr" indent="0" marL="0">
+            <a:pPr marL="0" indent="0" algn="ctr">
               <a:buNone/>
             </a:pPr>
             <a:r>
@@ -4340,7 +4387,7 @@
           <a:bodyPr wrap="square" lIns="0" tIns="0" rIns="0" bIns="0" rtlCol="0" anchor="ctr"/>
           <a:lstStyle/>
           <a:p>
-            <a:pPr algn="ctr" indent="0" marL="0">
+            <a:pPr marL="0" indent="0" algn="ctr">
               <a:lnSpc>
                 <a:spcPct val="105000"/>
               </a:lnSpc>
@@ -4360,7 +4407,7 @@
             <a:endParaRPr lang="en-US" sz="1300" dirty="0"/>
           </a:p>
           <a:p>
-            <a:pPr algn="ctr" indent="0" marL="0">
+            <a:pPr marL="0" indent="0" algn="ctr">
               <a:lnSpc>
                 <a:spcPct val="105000"/>
               </a:lnSpc>
@@ -4402,7 +4449,7 @@
           <a:bodyPr wrap="square" lIns="0" tIns="0" rIns="0" bIns="0" rtlCol="0" anchor="ctr"/>
           <a:lstStyle/>
           <a:p>
-            <a:pPr algn="ctr" indent="0" marL="0">
+            <a:pPr marL="0" indent="0" algn="ctr">
               <a:buNone/>
             </a:pPr>
             <a:r>
@@ -4446,13 +4493,20 @@
             <a:prstDash val="solid"/>
           </a:ln>
           <a:effectLst>
-            <a:outerShdw sx="100000" sy="100000" kx="0" ky="0" algn="bl" rotWithShape="0" blurRad="127000" dist="38100" dir="8100000">
+            <a:outerShdw blurRad="127000" dist="38100" dir="8100000" algn="bl" rotWithShape="0">
               <a:srgbClr val="000000">
                 <a:alpha val="10000"/>
               </a:srgbClr>
             </a:outerShdw>
           </a:effectLst>
         </p:spPr>
+        <p:txBody>
+          <a:bodyPr/>
+          <a:lstStyle/>
+          <a:p>
+            <a:endParaRPr lang="pl-PL"/>
+          </a:p>
+        </p:txBody>
       </p:sp>
       <p:sp>
         <p:nvSpPr>
@@ -4475,7 +4529,7 @@
           <a:bodyPr wrap="square" lIns="0" tIns="0" rIns="0" bIns="0" rtlCol="0" anchor="ctr"/>
           <a:lstStyle/>
           <a:p>
-            <a:pPr algn="ctr" indent="0" marL="0">
+            <a:pPr marL="0" indent="0" algn="ctr">
               <a:buNone/>
             </a:pPr>
             <a:r>
@@ -4514,7 +4568,7 @@
           <a:bodyPr wrap="square" lIns="0" tIns="0" rIns="0" bIns="0" rtlCol="0" anchor="ctr"/>
           <a:lstStyle/>
           <a:p>
-            <a:pPr algn="ctr" indent="0" marL="0">
+            <a:pPr marL="0" indent="0" algn="ctr">
               <a:lnSpc>
                 <a:spcPct val="105000"/>
               </a:lnSpc>
@@ -4534,7 +4588,7 @@
             <a:endParaRPr lang="en-US" sz="1300" dirty="0"/>
           </a:p>
           <a:p>
-            <a:pPr algn="ctr" indent="0" marL="0">
+            <a:pPr marL="0" indent="0" algn="ctr">
               <a:lnSpc>
                 <a:spcPct val="105000"/>
               </a:lnSpc>
@@ -4576,7 +4630,7 @@
           <a:bodyPr wrap="square" lIns="0" tIns="0" rIns="0" bIns="0" rtlCol="0" anchor="ctr"/>
           <a:lstStyle/>
           <a:p>
-            <a:pPr algn="ctr" indent="0" marL="0">
+            <a:pPr marL="0" indent="0" algn="ctr">
               <a:buNone/>
             </a:pPr>
             <a:r>
@@ -4620,13 +4674,20 @@
             <a:prstDash val="solid"/>
           </a:ln>
           <a:effectLst>
-            <a:outerShdw sx="100000" sy="100000" kx="0" ky="0" algn="bl" rotWithShape="0" blurRad="127000" dist="38100" dir="8100000">
+            <a:outerShdw blurRad="127000" dist="38100" dir="8100000" algn="bl" rotWithShape="0">
               <a:srgbClr val="000000">
                 <a:alpha val="10000"/>
               </a:srgbClr>
             </a:outerShdw>
           </a:effectLst>
         </p:spPr>
+        <p:txBody>
+          <a:bodyPr/>
+          <a:lstStyle/>
+          <a:p>
+            <a:endParaRPr lang="pl-PL"/>
+          </a:p>
+        </p:txBody>
       </p:sp>
       <p:sp>
         <p:nvSpPr>
@@ -4649,7 +4710,7 @@
           <a:bodyPr wrap="square" lIns="0" tIns="0" rIns="0" bIns="0" rtlCol="0" anchor="ctr"/>
           <a:lstStyle/>
           <a:p>
-            <a:pPr algn="ctr" indent="0" marL="0">
+            <a:pPr marL="0" indent="0" algn="ctr">
               <a:buNone/>
             </a:pPr>
             <a:r>
@@ -4688,7 +4749,7 @@
           <a:bodyPr wrap="square" lIns="0" tIns="0" rIns="0" bIns="0" rtlCol="0" anchor="ctr"/>
           <a:lstStyle/>
           <a:p>
-            <a:pPr algn="ctr" indent="0" marL="0">
+            <a:pPr marL="0" indent="0" algn="ctr">
               <a:lnSpc>
                 <a:spcPct val="105000"/>
               </a:lnSpc>
@@ -4708,7 +4769,7 @@
             <a:endParaRPr lang="en-US" sz="1300" dirty="0"/>
           </a:p>
           <a:p>
-            <a:pPr algn="ctr" indent="0" marL="0">
+            <a:pPr marL="0" indent="0" algn="ctr">
               <a:lnSpc>
                 <a:spcPct val="105000"/>
               </a:lnSpc>
@@ -4750,7 +4811,7 @@
           <a:bodyPr wrap="square" lIns="0" tIns="0" rIns="0" bIns="0" rtlCol="0" anchor="ctr"/>
           <a:lstStyle/>
           <a:p>
-            <a:pPr algn="ctr" indent="0" marL="0">
+            <a:pPr marL="0" indent="0" algn="ctr">
               <a:buNone/>
             </a:pPr>
             <a:r>
@@ -4794,13 +4855,20 @@
             <a:prstDash val="solid"/>
           </a:ln>
           <a:effectLst>
-            <a:outerShdw sx="100000" sy="100000" kx="0" ky="0" algn="bl" rotWithShape="0" blurRad="127000" dist="38100" dir="8100000">
+            <a:outerShdw blurRad="127000" dist="38100" dir="8100000" algn="bl" rotWithShape="0">
               <a:srgbClr val="000000">
                 <a:alpha val="10000"/>
               </a:srgbClr>
             </a:outerShdw>
           </a:effectLst>
         </p:spPr>
+        <p:txBody>
+          <a:bodyPr/>
+          <a:lstStyle/>
+          <a:p>
+            <a:endParaRPr lang="pl-PL"/>
+          </a:p>
+        </p:txBody>
       </p:sp>
       <p:sp>
         <p:nvSpPr>
@@ -4823,7 +4891,7 @@
           <a:bodyPr wrap="square" lIns="0" tIns="0" rIns="0" bIns="0" rtlCol="0" anchor="ctr"/>
           <a:lstStyle/>
           <a:p>
-            <a:pPr algn="ctr" indent="0" marL="0">
+            <a:pPr marL="0" indent="0" algn="ctr">
               <a:buNone/>
             </a:pPr>
             <a:r>
@@ -4862,7 +4930,7 @@
           <a:bodyPr wrap="square" lIns="0" tIns="0" rIns="0" bIns="0" rtlCol="0" anchor="ctr"/>
           <a:lstStyle/>
           <a:p>
-            <a:pPr algn="ctr" indent="0" marL="0">
+            <a:pPr marL="0" indent="0" algn="ctr">
               <a:lnSpc>
                 <a:spcPct val="105000"/>
               </a:lnSpc>
@@ -4882,7 +4950,7 @@
             <a:endParaRPr lang="en-US" sz="1300" dirty="0"/>
           </a:p>
           <a:p>
-            <a:pPr algn="ctr" indent="0" marL="0">
+            <a:pPr marL="0" indent="0" algn="ctr">
               <a:lnSpc>
                 <a:spcPct val="105000"/>
               </a:lnSpc>
@@ -4924,7 +4992,7 @@
           <a:bodyPr wrap="square" lIns="0" tIns="0" rIns="0" bIns="0" rtlCol="0" anchor="ctr"/>
           <a:lstStyle/>
           <a:p>
-            <a:pPr indent="0" marL="0">
+            <a:pPr marL="0" indent="0">
               <a:buNone/>
             </a:pPr>
             <a:r>
@@ -4936,7 +5004,73 @@
                 <a:ea typeface="Helvetica Neue" pitchFamily="34" charset="-122"/>
                 <a:cs typeface="Helvetica Neue" pitchFamily="34" charset="-120"/>
               </a:rPr>
-              <a:t>Każdy etap uwzględnia wnioski z poprzedniego — projekt powstawał krok po kroku, nie „na raz”.</a:t>
+              <a:t>Każdy etap uwzględnia wnioski z </a:t>
+            </a:r>
+            <a:r>
+              <a:rPr lang="en-US" sz="1400" i="1" dirty="0" err="1">
+                <a:solidFill>
+                  <a:srgbClr val="6E6E73"/>
+                </a:solidFill>
+                <a:latin typeface="Helvetica Neue" pitchFamily="34" charset="0"/>
+                <a:ea typeface="Helvetica Neue" pitchFamily="34" charset="-122"/>
+                <a:cs typeface="Helvetica Neue" pitchFamily="34" charset="-120"/>
+              </a:rPr>
+              <a:t>poprzedniego</a:t>
+            </a:r>
+            <a:r>
+              <a:rPr lang="en-US" sz="1400" i="1" dirty="0">
+                <a:solidFill>
+                  <a:srgbClr val="6E6E73"/>
+                </a:solidFill>
+                <a:latin typeface="Helvetica Neue" pitchFamily="34" charset="0"/>
+                <a:ea typeface="Helvetica Neue" pitchFamily="34" charset="-122"/>
+                <a:cs typeface="Helvetica Neue" pitchFamily="34" charset="-120"/>
+              </a:rPr>
+              <a:t> </a:t>
+            </a:r>
+            <a:r>
+              <a:rPr lang="pl-PL" sz="1400" i="1" dirty="0">
+                <a:solidFill>
+                  <a:srgbClr val="6E6E73"/>
+                </a:solidFill>
+                <a:latin typeface="Helvetica Neue" pitchFamily="34" charset="0"/>
+                <a:ea typeface="Helvetica Neue" pitchFamily="34" charset="-122"/>
+                <a:cs typeface="Helvetica Neue" pitchFamily="34" charset="-120"/>
+              </a:rPr>
+              <a:t>-</a:t>
+            </a:r>
+            <a:r>
+              <a:rPr lang="en-US" sz="1400" i="1" dirty="0">
+                <a:solidFill>
+                  <a:srgbClr val="6E6E73"/>
+                </a:solidFill>
+                <a:latin typeface="Helvetica Neue" pitchFamily="34" charset="0"/>
+                <a:ea typeface="Helvetica Neue" pitchFamily="34" charset="-122"/>
+                <a:cs typeface="Helvetica Neue" pitchFamily="34" charset="-120"/>
+              </a:rPr>
+              <a:t> projekt powstawał krok po </a:t>
+            </a:r>
+            <a:r>
+              <a:rPr lang="en-US" sz="1400" i="1" dirty="0" err="1">
+                <a:solidFill>
+                  <a:srgbClr val="6E6E73"/>
+                </a:solidFill>
+                <a:latin typeface="Helvetica Neue" pitchFamily="34" charset="0"/>
+                <a:ea typeface="Helvetica Neue" pitchFamily="34" charset="-122"/>
+                <a:cs typeface="Helvetica Neue" pitchFamily="34" charset="-120"/>
+              </a:rPr>
+              <a:t>kroku</a:t>
+            </a:r>
+            <a:r>
+              <a:rPr lang="en-US" sz="1400" i="1" dirty="0">
+                <a:solidFill>
+                  <a:srgbClr val="6E6E73"/>
+                </a:solidFill>
+                <a:latin typeface="Helvetica Neue" pitchFamily="34" charset="0"/>
+                <a:ea typeface="Helvetica Neue" pitchFamily="34" charset="-122"/>
+                <a:cs typeface="Helvetica Neue" pitchFamily="34" charset="-120"/>
+              </a:rPr>
+              <a:t>.</a:t>
             </a:r>
             <a:endParaRPr lang="en-US" sz="1400" dirty="0"/>
           </a:p>
@@ -4963,7 +5097,7 @@
           <a:bodyPr wrap="square" lIns="0" tIns="0" rIns="0" bIns="0" rtlCol="0" anchor="ctr"/>
           <a:lstStyle/>
           <a:p>
-            <a:pPr indent="0" marL="0">
+            <a:pPr marL="0" indent="0">
               <a:buNone/>
             </a:pPr>
             <a:r>
@@ -5002,7 +5136,7 @@
           <a:bodyPr wrap="square" lIns="0" tIns="0" rIns="0" bIns="0" rtlCol="0" anchor="ctr"/>
           <a:lstStyle/>
           <a:p>
-            <a:pPr algn="r" indent="0" marL="0">
+            <a:pPr marL="0" indent="0" algn="r">
               <a:buNone/>
             </a:pPr>
             <a:r>
@@ -5036,6 +5170,7 @@
         <a:solidFill>
           <a:srgbClr val="F5F5F7"/>
         </a:solidFill>
+        <a:effectLst/>
       </p:bgPr>
     </p:bg>
     <p:spTree>
@@ -5073,11 +5208,11 @@
           <a:bodyPr wrap="square" lIns="0" tIns="0" rIns="0" bIns="0" rtlCol="0" anchor="ctr"/>
           <a:lstStyle/>
           <a:p>
-            <a:pPr indent="0" marL="0">
+            <a:pPr marL="0" indent="0">
               <a:buNone/>
             </a:pPr>
             <a:r>
-              <a:rPr lang="en-US" sz="1300" b="1" spc="300" kern="0" dirty="0">
+              <a:rPr lang="en-US" sz="1300" b="1" kern="0" spc="300" dirty="0">
                 <a:solidFill>
                   <a:srgbClr val="6E6E73"/>
                 </a:solidFill>
@@ -5112,7 +5247,7 @@
           <a:bodyPr wrap="square" lIns="0" tIns="0" rIns="0" bIns="0" rtlCol="0" anchor="ctr"/>
           <a:lstStyle/>
           <a:p>
-            <a:pPr indent="0" marL="0">
+            <a:pPr marL="0" indent="0">
               <a:lnSpc>
                 <a:spcPct val="100000"/>
               </a:lnSpc>
@@ -5165,7 +5300,7 @@
               <a:buChar char="•"/>
             </a:pPr>
             <a:r>
-              <a:rPr lang="en-US" sz="1500" b="1" dirty="0">
+              <a:rPr lang="en-US" sz="1500" b="1" dirty="0" err="1">
                 <a:solidFill>
                   <a:srgbClr val="1D1D1F"/>
                 </a:solidFill>
@@ -5175,15 +5310,6 @@
               </a:rPr>
               <a:t>Monochromatycznie</a:t>
             </a:r>
-            <a:pPr indent="0" marL="0">
-              <a:lnSpc>
-                <a:spcPct val="115000"/>
-              </a:lnSpc>
-              <a:spcAft>
-                <a:spcPts val="1000"/>
-              </a:spcAft>
-              <a:buNone/>
-            </a:pPr>
             <a:r>
               <a:rPr lang="en-US" sz="1500" dirty="0">
                 <a:solidFill>
@@ -5193,7 +5319,7 @@
                 <a:ea typeface="Helvetica Neue" pitchFamily="34" charset="-122"/>
                 <a:cs typeface="Helvetica Neue" pitchFamily="34" charset="-120"/>
               </a:rPr>
-              <a:t> — kolor tylko funkcjonalnie (czerwień terminu/usuwania).</a:t>
+              <a:t> - kolor tylko funkcjonalnie (czerwień terminu/usuwania).</a:t>
             </a:r>
             <a:endParaRPr lang="en-US" sz="1500" dirty="0"/>
           </a:p>
@@ -5219,15 +5345,6 @@
               </a:rPr>
               <a:t>Dużo przestrzeni</a:t>
             </a:r>
-            <a:pPr indent="0" marL="0">
-              <a:lnSpc>
-                <a:spcPct val="115000"/>
-              </a:lnSpc>
-              <a:spcAft>
-                <a:spcPts val="1000"/>
-              </a:spcAft>
-              <a:buNone/>
-            </a:pPr>
             <a:r>
               <a:rPr lang="en-US" sz="1500" dirty="0">
                 <a:solidFill>
@@ -5261,17 +5378,19 @@
                 <a:ea typeface="Helvetica Neue" pitchFamily="34" charset="-122"/>
                 <a:cs typeface="Helvetica Neue" pitchFamily="34" charset="-120"/>
               </a:rPr>
-              <a:t>Spójne komponenty</a:t>
-            </a:r>
-            <a:pPr indent="0" marL="0">
-              <a:lnSpc>
-                <a:spcPct val="115000"/>
-              </a:lnSpc>
-              <a:spcAft>
-                <a:spcPts val="1000"/>
-              </a:spcAft>
-              <a:buNone/>
-            </a:pPr>
+              <a:t>Spójne </a:t>
+            </a:r>
+            <a:r>
+              <a:rPr lang="en-US" sz="1500" b="1" dirty="0" err="1">
+                <a:solidFill>
+                  <a:srgbClr val="1D1D1F"/>
+                </a:solidFill>
+                <a:latin typeface="Helvetica Neue" pitchFamily="34" charset="0"/>
+                <a:ea typeface="Helvetica Neue" pitchFamily="34" charset="-122"/>
+                <a:cs typeface="Helvetica Neue" pitchFamily="34" charset="-120"/>
+              </a:rPr>
+              <a:t>komponenty</a:t>
+            </a:r>
             <a:r>
               <a:rPr lang="en-US" sz="1500" dirty="0">
                 <a:solidFill>
@@ -5281,7 +5400,7 @@
                 <a:ea typeface="Helvetica Neue" pitchFamily="34" charset="-122"/>
                 <a:cs typeface="Helvetica Neue" pitchFamily="34" charset="-120"/>
               </a:rPr>
-              <a:t> — jeden zestaw kart, pól i przycisków-pigułek.</a:t>
+              <a:t> - jeden zestaw kart, pól i przycisków-pigułek.</a:t>
             </a:r>
             <a:endParaRPr lang="en-US" sz="1500" dirty="0"/>
           </a:p>
@@ -5305,17 +5424,41 @@
                 <a:ea typeface="Helvetica Neue" pitchFamily="34" charset="-122"/>
                 <a:cs typeface="Helvetica Neue" pitchFamily="34" charset="-120"/>
               </a:rPr>
-              <a:t>Tryb jasny i ciemny</a:t>
-            </a:r>
-            <a:pPr indent="0" marL="0">
-              <a:lnSpc>
-                <a:spcPct val="115000"/>
-              </a:lnSpc>
-              <a:spcAft>
-                <a:spcPts val="1000"/>
-              </a:spcAft>
-              <a:buNone/>
-            </a:pPr>
+              <a:t>Tryb jasny </a:t>
+            </a:r>
+            <a:r>
+              <a:rPr lang="en-US" sz="1500" b="1" dirty="0" err="1">
+                <a:solidFill>
+                  <a:srgbClr val="1D1D1F"/>
+                </a:solidFill>
+                <a:latin typeface="Helvetica Neue" pitchFamily="34" charset="0"/>
+                <a:ea typeface="Helvetica Neue" pitchFamily="34" charset="-122"/>
+                <a:cs typeface="Helvetica Neue" pitchFamily="34" charset="-120"/>
+              </a:rPr>
+              <a:t>i</a:t>
+            </a:r>
+            <a:r>
+              <a:rPr lang="en-US" sz="1500" b="1" dirty="0">
+                <a:solidFill>
+                  <a:srgbClr val="1D1D1F"/>
+                </a:solidFill>
+                <a:latin typeface="Helvetica Neue" pitchFamily="34" charset="0"/>
+                <a:ea typeface="Helvetica Neue" pitchFamily="34" charset="-122"/>
+                <a:cs typeface="Helvetica Neue" pitchFamily="34" charset="-120"/>
+              </a:rPr>
+              <a:t> </a:t>
+            </a:r>
+            <a:r>
+              <a:rPr lang="en-US" sz="1500" b="1" dirty="0" err="1">
+                <a:solidFill>
+                  <a:srgbClr val="1D1D1F"/>
+                </a:solidFill>
+                <a:latin typeface="Helvetica Neue" pitchFamily="34" charset="0"/>
+                <a:ea typeface="Helvetica Neue" pitchFamily="34" charset="-122"/>
+                <a:cs typeface="Helvetica Neue" pitchFamily="34" charset="-120"/>
+              </a:rPr>
+              <a:t>ciemny</a:t>
+            </a:r>
             <a:r>
               <a:rPr lang="en-US" sz="1500" dirty="0">
                 <a:solidFill>
@@ -5325,7 +5468,7 @@
                 <a:ea typeface="Helvetica Neue" pitchFamily="34" charset="-122"/>
                 <a:cs typeface="Helvetica Neue" pitchFamily="34" charset="-120"/>
               </a:rPr>
-              <a:t> jako realna funkcja.</a:t>
+              <a:t>.</a:t>
             </a:r>
             <a:endParaRPr lang="en-US" sz="1500" dirty="0"/>
           </a:p>
@@ -5333,15 +5476,15 @@
       </p:sp>
       <p:pic>
         <p:nvPicPr>
-          <p:cNvPr id="5" name="Image 0" descr="/tmp/readlab-pptx/wireframe-lista.png">    </p:cNvPr>
+          <p:cNvPr id="5" name="Image 0" descr="/tmp/readlab-pptx/wireframe-lista.png"/>
           <p:cNvPicPr>
             <a:picLocks noChangeAspect="1"/>
           </p:cNvPicPr>
           <p:nvPr/>
         </p:nvPicPr>
         <p:blipFill>
-          <a:blip r:embed="rId1"/>
-          <a:srcRect l="0" r="0" t="0" b="0"/>
+          <a:blip r:embed="rId3"/>
+          <a:srcRect/>
           <a:stretch/>
         </p:blipFill>
         <p:spPr>
@@ -5375,7 +5518,7 @@
           <a:bodyPr wrap="square" lIns="0" tIns="0" rIns="0" bIns="0" rtlCol="0" anchor="ctr"/>
           <a:lstStyle/>
           <a:p>
-            <a:pPr algn="ctr" indent="0" marL="0">
+            <a:pPr marL="0" indent="0" algn="ctr">
               <a:buNone/>
             </a:pPr>
             <a:r>
@@ -5414,7 +5557,7 @@
           <a:bodyPr wrap="square" lIns="0" tIns="0" rIns="0" bIns="0" rtlCol="0" anchor="ctr"/>
           <a:lstStyle/>
           <a:p>
-            <a:pPr indent="0" marL="0">
+            <a:pPr marL="0" indent="0">
               <a:buNone/>
             </a:pPr>
             <a:r>
@@ -5453,7 +5596,7 @@
           <a:bodyPr wrap="square" lIns="0" tIns="0" rIns="0" bIns="0" rtlCol="0" anchor="ctr"/>
           <a:lstStyle/>
           <a:p>
-            <a:pPr algn="r" indent="0" marL="0">
+            <a:pPr marL="0" indent="0" algn="r">
               <a:buNone/>
             </a:pPr>
             <a:r>
@@ -5487,6 +5630,7 @@
         <a:solidFill>
           <a:srgbClr val="F5F5F7"/>
         </a:solidFill>
+        <a:effectLst/>
       </p:bgPr>
     </p:bg>
     <p:spTree>
@@ -5524,11 +5668,11 @@
           <a:bodyPr wrap="square" lIns="0" tIns="0" rIns="0" bIns="0" rtlCol="0" anchor="ctr"/>
           <a:lstStyle/>
           <a:p>
-            <a:pPr indent="0" marL="0">
+            <a:pPr marL="0" indent="0">
               <a:buNone/>
             </a:pPr>
             <a:r>
-              <a:rPr lang="en-US" sz="1300" b="1" spc="300" kern="0" dirty="0">
+              <a:rPr lang="en-US" sz="1300" b="1" kern="0" spc="300" dirty="0">
                 <a:solidFill>
                   <a:srgbClr val="6E6E73"/>
                 </a:solidFill>
@@ -5563,7 +5707,7 @@
           <a:bodyPr wrap="square" lIns="0" tIns="0" rIns="0" bIns="0" rtlCol="0" anchor="ctr"/>
           <a:lstStyle/>
           <a:p>
-            <a:pPr indent="0" marL="0">
+            <a:pPr marL="0" indent="0">
               <a:lnSpc>
                 <a:spcPct val="100000"/>
               </a:lnSpc>
@@ -5586,15 +5730,15 @@
       </p:sp>
       <p:pic>
         <p:nvPicPr>
-          <p:cNvPr id="4" name="Image 0" descr="/tmp/readlab-pptx/user-flow.jpg">    </p:cNvPr>
+          <p:cNvPr id="4" name="Image 0" descr="/tmp/readlab-pptx/user-flow.jpg"/>
           <p:cNvPicPr>
             <a:picLocks noChangeAspect="1"/>
           </p:cNvPicPr>
           <p:nvPr/>
         </p:nvPicPr>
         <p:blipFill>
-          <a:blip r:embed="rId1"/>
-          <a:srcRect l="0" r="0" t="0" b="0"/>
+          <a:blip r:embed="rId3"/>
+          <a:srcRect/>
           <a:stretch/>
         </p:blipFill>
         <p:spPr>
@@ -5628,7 +5772,7 @@
           <a:bodyPr wrap="square" lIns="0" tIns="0" rIns="0" bIns="0" rtlCol="0" anchor="ctr"/>
           <a:lstStyle/>
           <a:p>
-            <a:pPr indent="0" marL="0">
+            <a:pPr marL="0" indent="0">
               <a:buNone/>
             </a:pPr>
             <a:r>
@@ -5667,7 +5811,7 @@
           <a:bodyPr wrap="square" lIns="0" tIns="0" rIns="0" bIns="0" rtlCol="0" anchor="ctr"/>
           <a:lstStyle/>
           <a:p>
-            <a:pPr algn="r" indent="0" marL="0">
+            <a:pPr marL="0" indent="0" algn="r">
               <a:buNone/>
             </a:pPr>
             <a:r>
@@ -5701,6 +5845,7 @@
         <a:solidFill>
           <a:srgbClr val="F5F5F7"/>
         </a:solidFill>
+        <a:effectLst/>
       </p:bgPr>
     </p:bg>
     <p:spTree>
@@ -5738,11 +5883,11 @@
           <a:bodyPr wrap="square" lIns="0" tIns="0" rIns="0" bIns="0" rtlCol="0" anchor="ctr"/>
           <a:lstStyle/>
           <a:p>
-            <a:pPr indent="0" marL="0">
+            <a:pPr marL="0" indent="0">
               <a:buNone/>
             </a:pPr>
             <a:r>
-              <a:rPr lang="en-US" sz="1300" b="1" spc="300" kern="0" dirty="0">
+              <a:rPr lang="en-US" sz="1300" b="1" kern="0" spc="300" dirty="0">
                 <a:solidFill>
                   <a:srgbClr val="6E6E73"/>
                 </a:solidFill>
@@ -5777,7 +5922,7 @@
           <a:bodyPr wrap="square" lIns="0" tIns="0" rIns="0" bIns="0" rtlCol="0" anchor="ctr"/>
           <a:lstStyle/>
           <a:p>
-            <a:pPr indent="0" marL="0">
+            <a:pPr marL="0" indent="0">
               <a:lnSpc>
                 <a:spcPct val="100000"/>
               </a:lnSpc>
@@ -5824,13 +5969,20 @@
             <a:prstDash val="solid"/>
           </a:ln>
           <a:effectLst>
-            <a:outerShdw sx="100000" sy="100000" kx="0" ky="0" algn="bl" rotWithShape="0" blurRad="127000" dist="38100" dir="8100000">
+            <a:outerShdw blurRad="127000" dist="38100" dir="8100000" algn="bl" rotWithShape="0">
               <a:srgbClr val="000000">
                 <a:alpha val="10000"/>
               </a:srgbClr>
             </a:outerShdw>
           </a:effectLst>
         </p:spPr>
+        <p:txBody>
+          <a:bodyPr/>
+          <a:lstStyle/>
+          <a:p>
+            <a:endParaRPr lang="pl-PL"/>
+          </a:p>
+        </p:txBody>
       </p:sp>
       <p:sp>
         <p:nvSpPr>
@@ -5853,7 +6005,7 @@
           <a:bodyPr wrap="square" lIns="0" tIns="0" rIns="0" bIns="0" rtlCol="0" anchor="ctr"/>
           <a:lstStyle/>
           <a:p>
-            <a:pPr indent="0" marL="0">
+            <a:pPr marL="0" indent="0">
               <a:buNone/>
             </a:pPr>
             <a:r>
@@ -5982,13 +6134,20 @@
             <a:prstDash val="solid"/>
           </a:ln>
           <a:effectLst>
-            <a:outerShdw sx="100000" sy="100000" kx="0" ky="0" algn="bl" rotWithShape="0" blurRad="127000" dist="38100" dir="8100000">
+            <a:outerShdw blurRad="127000" dist="38100" dir="8100000" algn="bl" rotWithShape="0">
               <a:srgbClr val="000000">
                 <a:alpha val="10000"/>
               </a:srgbClr>
             </a:outerShdw>
           </a:effectLst>
         </p:spPr>
+        <p:txBody>
+          <a:bodyPr/>
+          <a:lstStyle/>
+          <a:p>
+            <a:endParaRPr lang="pl-PL"/>
+          </a:p>
+        </p:txBody>
       </p:sp>
       <p:sp>
         <p:nvSpPr>
@@ -6011,7 +6170,7 @@
           <a:bodyPr wrap="square" lIns="0" tIns="0" rIns="0" bIns="0" rtlCol="0" anchor="ctr"/>
           <a:lstStyle/>
           <a:p>
-            <a:pPr indent="0" marL="0">
+            <a:pPr marL="0" indent="0">
               <a:buNone/>
             </a:pPr>
             <a:r>
@@ -6135,7 +6294,7 @@
           <a:bodyPr wrap="square" lIns="0" tIns="0" rIns="0" bIns="0" rtlCol="0" anchor="ctr"/>
           <a:lstStyle/>
           <a:p>
-            <a:pPr indent="0" marL="0">
+            <a:pPr marL="0" indent="0">
               <a:buNone/>
             </a:pPr>
             <a:r>
@@ -6147,7 +6306,7 @@
                 <a:ea typeface="Helvetica Neue" pitchFamily="34" charset="-122"/>
                 <a:cs typeface="Helvetica Neue" pitchFamily="34" charset="-120"/>
               </a:rPr>
-              <a:t>Responsywność: desktop — kanban z przeciąganiem; mobile — segmentowany przełącznik statusów.</a:t>
+              <a:t>Responsywność: desktop - kanban z przeciąganiem; mobile - segmentowany przełącznik statusów.</a:t>
             </a:r>
             <a:endParaRPr lang="en-US" sz="1300" dirty="0"/>
           </a:p>
@@ -6174,7 +6333,7 @@
           <a:bodyPr wrap="square" lIns="0" tIns="0" rIns="0" bIns="0" rtlCol="0" anchor="ctr"/>
           <a:lstStyle/>
           <a:p>
-            <a:pPr indent="0" marL="0">
+            <a:pPr marL="0" indent="0">
               <a:buNone/>
             </a:pPr>
             <a:r>
@@ -6213,7 +6372,7 @@
           <a:bodyPr wrap="square" lIns="0" tIns="0" rIns="0" bIns="0" rtlCol="0" anchor="ctr"/>
           <a:lstStyle/>
           <a:p>
-            <a:pPr algn="r" indent="0" marL="0">
+            <a:pPr marL="0" indent="0" algn="r">
               <a:buNone/>
             </a:pPr>
             <a:r>
@@ -6247,6 +6406,7 @@
         <a:solidFill>
           <a:srgbClr val="F5F5F7"/>
         </a:solidFill>
+        <a:effectLst/>
       </p:bgPr>
     </p:bg>
     <p:spTree>
@@ -6284,11 +6444,11 @@
           <a:bodyPr wrap="square" lIns="0" tIns="0" rIns="0" bIns="0" rtlCol="0" anchor="ctr"/>
           <a:lstStyle/>
           <a:p>
-            <a:pPr indent="0" marL="0">
+            <a:pPr marL="0" indent="0">
               <a:buNone/>
             </a:pPr>
             <a:r>
-              <a:rPr lang="en-US" sz="1300" b="1" spc="300" kern="0" dirty="0">
+              <a:rPr lang="en-US" sz="1300" b="1" kern="0" spc="300" dirty="0">
                 <a:solidFill>
                   <a:srgbClr val="6E6E73"/>
                 </a:solidFill>
@@ -6323,7 +6483,7 @@
           <a:bodyPr wrap="square" lIns="0" tIns="0" rIns="0" bIns="0" rtlCol="0" anchor="ctr"/>
           <a:lstStyle/>
           <a:p>
-            <a:pPr indent="0" marL="0">
+            <a:pPr marL="0" indent="0">
               <a:lnSpc>
                 <a:spcPct val="100000"/>
               </a:lnSpc>
@@ -6386,15 +6546,6 @@
               </a:rPr>
               <a:t>Trzy statusy zamiast „wykonane” </a:t>
             </a:r>
-            <a:pPr indent="0" marL="0">
-              <a:lnSpc>
-                <a:spcPct val="110000"/>
-              </a:lnSpc>
-              <a:spcAft>
-                <a:spcPts val="1400"/>
-              </a:spcAft>
-              <a:buNone/>
-            </a:pPr>
             <a:r>
               <a:rPr lang="en-US" sz="1600" dirty="0">
                 <a:solidFill>
@@ -6404,7 +6555,84 @@
                 <a:ea typeface="Helvetica Neue" pitchFamily="34" charset="-122"/>
                 <a:cs typeface="Helvetica Neue" pitchFamily="34" charset="-120"/>
               </a:rPr>
-              <a:t>— odwzorowują realny cykl życia książki („coś więcej niż to-do”).</a:t>
+              <a:t>– </a:t>
+            </a:r>
+            <a:r>
+              <a:rPr lang="en-US" sz="1600" dirty="0" err="1">
+                <a:solidFill>
+                  <a:srgbClr val="1D1D1F"/>
+                </a:solidFill>
+                <a:latin typeface="Helvetica Neue" pitchFamily="34" charset="0"/>
+                <a:ea typeface="Helvetica Neue" pitchFamily="34" charset="-122"/>
+                <a:cs typeface="Helvetica Neue" pitchFamily="34" charset="-120"/>
+              </a:rPr>
+              <a:t>odwzorowują</a:t>
+            </a:r>
+            <a:r>
+              <a:rPr lang="pl-PL" sz="1600" dirty="0">
+                <a:solidFill>
+                  <a:srgbClr val="1D1D1F"/>
+                </a:solidFill>
+                <a:latin typeface="Helvetica Neue" pitchFamily="34" charset="0"/>
+                <a:ea typeface="Helvetica Neue" pitchFamily="34" charset="-122"/>
+                <a:cs typeface="Helvetica Neue" pitchFamily="34" charset="-120"/>
+              </a:rPr>
+              <a:t> </a:t>
+            </a:r>
+            <a:r>
+              <a:rPr lang="en-US" sz="1600" dirty="0" err="1">
+                <a:solidFill>
+                  <a:srgbClr val="1D1D1F"/>
+                </a:solidFill>
+                <a:latin typeface="Helvetica Neue" pitchFamily="34" charset="0"/>
+                <a:ea typeface="Helvetica Neue" pitchFamily="34" charset="-122"/>
+                <a:cs typeface="Helvetica Neue" pitchFamily="34" charset="-120"/>
+              </a:rPr>
+              <a:t>cykl</a:t>
+            </a:r>
+            <a:r>
+              <a:rPr lang="en-US" sz="1600" dirty="0">
+                <a:solidFill>
+                  <a:srgbClr val="1D1D1F"/>
+                </a:solidFill>
+                <a:latin typeface="Helvetica Neue" pitchFamily="34" charset="0"/>
+                <a:ea typeface="Helvetica Neue" pitchFamily="34" charset="-122"/>
+                <a:cs typeface="Helvetica Neue" pitchFamily="34" charset="-120"/>
+              </a:rPr>
+              <a:t> </a:t>
+            </a:r>
+            <a:r>
+              <a:rPr lang="en-US" sz="1600" dirty="0" err="1">
+                <a:solidFill>
+                  <a:srgbClr val="1D1D1F"/>
+                </a:solidFill>
+                <a:latin typeface="Helvetica Neue" pitchFamily="34" charset="0"/>
+                <a:ea typeface="Helvetica Neue" pitchFamily="34" charset="-122"/>
+                <a:cs typeface="Helvetica Neue" pitchFamily="34" charset="-120"/>
+              </a:rPr>
+              <a:t>życia</a:t>
+            </a:r>
+            <a:r>
+              <a:rPr lang="en-US" sz="1600" dirty="0">
+                <a:solidFill>
+                  <a:srgbClr val="1D1D1F"/>
+                </a:solidFill>
+                <a:latin typeface="Helvetica Neue" pitchFamily="34" charset="0"/>
+                <a:ea typeface="Helvetica Neue" pitchFamily="34" charset="-122"/>
+                <a:cs typeface="Helvetica Neue" pitchFamily="34" charset="-120"/>
+              </a:rPr>
+              <a:t> </a:t>
+            </a:r>
+            <a:r>
+              <a:rPr lang="en-US" sz="1600">
+                <a:solidFill>
+                  <a:srgbClr val="1D1D1F"/>
+                </a:solidFill>
+                <a:latin typeface="Helvetica Neue" pitchFamily="34" charset="0"/>
+                <a:ea typeface="Helvetica Neue" pitchFamily="34" charset="-122"/>
+                <a:cs typeface="Helvetica Neue" pitchFamily="34" charset="-120"/>
+              </a:rPr>
+              <a:t>książki.</a:t>
             </a:r>
             <a:endParaRPr lang="en-US" sz="1600" dirty="0"/>
           </a:p>
@@ -6428,17 +6656,30 @@
                 <a:ea typeface="Helvetica Neue" pitchFamily="34" charset="-122"/>
                 <a:cs typeface="Helvetica Neue" pitchFamily="34" charset="-120"/>
               </a:rPr>
-              <a:t>Kanban / zakładki </a:t>
-            </a:r>
-            <a:pPr indent="0" marL="0">
-              <a:lnSpc>
-                <a:spcPct val="110000"/>
-              </a:lnSpc>
-              <a:spcAft>
-                <a:spcPts val="1400"/>
-              </a:spcAft>
-              <a:buNone/>
-            </a:pPr>
+              <a:t>Kanban / </a:t>
+            </a:r>
+            <a:r>
+              <a:rPr lang="en-US" sz="1600" b="1" dirty="0" err="1">
+                <a:solidFill>
+                  <a:srgbClr val="1D1D1F"/>
+                </a:solidFill>
+                <a:latin typeface="Helvetica Neue" pitchFamily="34" charset="0"/>
+                <a:ea typeface="Helvetica Neue" pitchFamily="34" charset="-122"/>
+                <a:cs typeface="Helvetica Neue" pitchFamily="34" charset="-120"/>
+              </a:rPr>
+              <a:t>zakładki</a:t>
+            </a:r>
+            <a:r>
+              <a:rPr lang="en-US" sz="1600" b="1" dirty="0">
+                <a:solidFill>
+                  <a:srgbClr val="1D1D1F"/>
+                </a:solidFill>
+                <a:latin typeface="Helvetica Neue" pitchFamily="34" charset="0"/>
+                <a:ea typeface="Helvetica Neue" pitchFamily="34" charset="-122"/>
+                <a:cs typeface="Helvetica Neue" pitchFamily="34" charset="-120"/>
+              </a:rPr>
+              <a:t> </a:t>
+            </a:r>
             <a:r>
               <a:rPr lang="en-US" sz="1600" dirty="0">
                 <a:solidFill>
@@ -6448,7 +6689,7 @@
                 <a:ea typeface="Helvetica Neue" pitchFamily="34" charset="-122"/>
                 <a:cs typeface="Helvetica Neue" pitchFamily="34" charset="-120"/>
               </a:rPr>
-              <a:t>— ta sama logika w dwóch układach = responsywność bez utraty spójności.</a:t>
+              <a:t>- ta sama logika w dwóch układach = responsywność bez utraty spójności.</a:t>
             </a:r>
             <a:endParaRPr lang="en-US" sz="1600" dirty="0"/>
           </a:p>
@@ -6472,17 +6713,30 @@
                 <a:ea typeface="Helvetica Neue" pitchFamily="34" charset="-122"/>
                 <a:cs typeface="Helvetica Neue" pitchFamily="34" charset="-120"/>
               </a:rPr>
-              <a:t>Tylko tytuł wymagany </a:t>
-            </a:r>
-            <a:pPr indent="0" marL="0">
-              <a:lnSpc>
-                <a:spcPct val="110000"/>
-              </a:lnSpc>
-              <a:spcAft>
-                <a:spcPts val="1400"/>
-              </a:spcAft>
-              <a:buNone/>
-            </a:pPr>
+              <a:t>Tylko tytuł </a:t>
+            </a:r>
+            <a:r>
+              <a:rPr lang="en-US" sz="1600" b="1" dirty="0" err="1">
+                <a:solidFill>
+                  <a:srgbClr val="1D1D1F"/>
+                </a:solidFill>
+                <a:latin typeface="Helvetica Neue" pitchFamily="34" charset="0"/>
+                <a:ea typeface="Helvetica Neue" pitchFamily="34" charset="-122"/>
+                <a:cs typeface="Helvetica Neue" pitchFamily="34" charset="-120"/>
+              </a:rPr>
+              <a:t>wymagany</a:t>
+            </a:r>
+            <a:r>
+              <a:rPr lang="en-US" sz="1600" b="1" dirty="0">
+                <a:solidFill>
+                  <a:srgbClr val="1D1D1F"/>
+                </a:solidFill>
+                <a:latin typeface="Helvetica Neue" pitchFamily="34" charset="0"/>
+                <a:ea typeface="Helvetica Neue" pitchFamily="34" charset="-122"/>
+                <a:cs typeface="Helvetica Neue" pitchFamily="34" charset="-120"/>
+              </a:rPr>
+              <a:t> </a:t>
+            </a:r>
             <a:r>
               <a:rPr lang="en-US" sz="1600" dirty="0">
                 <a:solidFill>
@@ -6492,7 +6746,7 @@
                 <a:ea typeface="Helvetica Neue" pitchFamily="34" charset="-122"/>
                 <a:cs typeface="Helvetica Neue" pitchFamily="34" charset="-120"/>
               </a:rPr>
-              <a:t>— szybkie dodawanie; reszta pól opcjonalna.</a:t>
+              <a:t>- szybkie dodawanie; reszta pól opcjonalna.</a:t>
             </a:r>
             <a:endParaRPr lang="en-US" sz="1600" dirty="0"/>
           </a:p>
@@ -6516,17 +6770,30 @@
                 <a:ea typeface="Helvetica Neue" pitchFamily="34" charset="-122"/>
                 <a:cs typeface="Helvetica Neue" pitchFamily="34" charset="-120"/>
               </a:rPr>
-              <a:t>Potwierdzenie usuwania </a:t>
-            </a:r>
-            <a:pPr indent="0" marL="0">
-              <a:lnSpc>
-                <a:spcPct val="110000"/>
-              </a:lnSpc>
-              <a:spcAft>
-                <a:spcPts val="1400"/>
-              </a:spcAft>
-              <a:buNone/>
-            </a:pPr>
+              <a:t>Potwierdzenie </a:t>
+            </a:r>
+            <a:r>
+              <a:rPr lang="en-US" sz="1600" b="1" dirty="0" err="1">
+                <a:solidFill>
+                  <a:srgbClr val="1D1D1F"/>
+                </a:solidFill>
+                <a:latin typeface="Helvetica Neue" pitchFamily="34" charset="0"/>
+                <a:ea typeface="Helvetica Neue" pitchFamily="34" charset="-122"/>
+                <a:cs typeface="Helvetica Neue" pitchFamily="34" charset="-120"/>
+              </a:rPr>
+              <a:t>usuwania</a:t>
+            </a:r>
+            <a:r>
+              <a:rPr lang="en-US" sz="1600" b="1" dirty="0">
+                <a:solidFill>
+                  <a:srgbClr val="1D1D1F"/>
+                </a:solidFill>
+                <a:latin typeface="Helvetica Neue" pitchFamily="34" charset="0"/>
+                <a:ea typeface="Helvetica Neue" pitchFamily="34" charset="-122"/>
+                <a:cs typeface="Helvetica Neue" pitchFamily="34" charset="-120"/>
+              </a:rPr>
+              <a:t> </a:t>
+            </a:r>
             <a:r>
               <a:rPr lang="en-US" sz="1600" dirty="0">
                 <a:solidFill>
@@ -6536,7 +6803,7 @@
                 <a:ea typeface="Helvetica Neue" pitchFamily="34" charset="-122"/>
                 <a:cs typeface="Helvetica Neue" pitchFamily="34" charset="-120"/>
               </a:rPr>
-              <a:t>— ochrona przed przypadkową utratą danych.</a:t>
+              <a:t>- ochrona przed przypadkową utratą danych.</a:t>
             </a:r>
             <a:endParaRPr lang="en-US" sz="1600" dirty="0"/>
           </a:p>
@@ -6560,17 +6827,30 @@
                 <a:ea typeface="Helvetica Neue" pitchFamily="34" charset="-122"/>
                 <a:cs typeface="Helvetica Neue" pitchFamily="34" charset="-120"/>
               </a:rPr>
-              <a:t>localStorage zamiast backendu </a:t>
-            </a:r>
-            <a:pPr indent="0" marL="0">
-              <a:lnSpc>
-                <a:spcPct val="110000"/>
-              </a:lnSpc>
-              <a:spcAft>
-                <a:spcPts val="1400"/>
-              </a:spcAft>
-              <a:buNone/>
-            </a:pPr>
+              <a:t>localStorage zamiast </a:t>
+            </a:r>
+            <a:r>
+              <a:rPr lang="en-US" sz="1600" b="1" dirty="0" err="1">
+                <a:solidFill>
+                  <a:srgbClr val="1D1D1F"/>
+                </a:solidFill>
+                <a:latin typeface="Helvetica Neue" pitchFamily="34" charset="0"/>
+                <a:ea typeface="Helvetica Neue" pitchFamily="34" charset="-122"/>
+                <a:cs typeface="Helvetica Neue" pitchFamily="34" charset="-120"/>
+              </a:rPr>
+              <a:t>backendu</a:t>
+            </a:r>
+            <a:r>
+              <a:rPr lang="en-US" sz="1600" b="1" dirty="0">
+                <a:solidFill>
+                  <a:srgbClr val="1D1D1F"/>
+                </a:solidFill>
+                <a:latin typeface="Helvetica Neue" pitchFamily="34" charset="0"/>
+                <a:ea typeface="Helvetica Neue" pitchFamily="34" charset="-122"/>
+                <a:cs typeface="Helvetica Neue" pitchFamily="34" charset="-120"/>
+              </a:rPr>
+              <a:t> </a:t>
+            </a:r>
             <a:r>
               <a:rPr lang="en-US" sz="1600" dirty="0">
                 <a:solidFill>
@@ -6580,7 +6860,7 @@
                 <a:ea typeface="Helvetica Neue" pitchFamily="34" charset="-122"/>
                 <a:cs typeface="Helvetica Neue" pitchFamily="34" charset="-120"/>
               </a:rPr>
-              <a:t>— zgodne z wymaganiami; cały wysiłek idzie w UX/UI.</a:t>
+              <a:t>- zgodne z wymaganiami; cały wysiłek idzie w UX/UI.</a:t>
             </a:r>
             <a:endParaRPr lang="en-US" sz="1600" dirty="0"/>
           </a:p>
@@ -6607,7 +6887,7 @@
           <a:bodyPr wrap="square" lIns="0" tIns="0" rIns="0" bIns="0" rtlCol="0" anchor="ctr"/>
           <a:lstStyle/>
           <a:p>
-            <a:pPr indent="0" marL="0">
+            <a:pPr marL="0" indent="0">
               <a:buNone/>
             </a:pPr>
             <a:r>
@@ -6646,7 +6926,7 @@
           <a:bodyPr wrap="square" lIns="0" tIns="0" rIns="0" bIns="0" rtlCol="0" anchor="ctr"/>
           <a:lstStyle/>
           <a:p>
-            <a:pPr algn="r" indent="0" marL="0">
+            <a:pPr marL="0" indent="0" algn="r">
               <a:buNone/>
             </a:pPr>
             <a:r>
@@ -6680,6 +6960,7 @@
         <a:solidFill>
           <a:srgbClr val="F5F5F7"/>
         </a:solidFill>
+        <a:effectLst/>
       </p:bgPr>
     </p:bg>
     <p:spTree>
@@ -6717,11 +6998,11 @@
           <a:bodyPr wrap="square" lIns="0" tIns="0" rIns="0" bIns="0" rtlCol="0" anchor="ctr"/>
           <a:lstStyle/>
           <a:p>
-            <a:pPr indent="0" marL="0">
+            <a:pPr marL="0" indent="0">
               <a:buNone/>
             </a:pPr>
             <a:r>
-              <a:rPr lang="en-US" sz="1300" b="1" spc="300" kern="0" dirty="0">
+              <a:rPr lang="en-US" sz="1300" b="1" kern="0" spc="300" dirty="0">
                 <a:solidFill>
                   <a:srgbClr val="6E6E73"/>
                 </a:solidFill>
@@ -6756,7 +7037,7 @@
           <a:bodyPr wrap="square" lIns="0" tIns="0" rIns="0" bIns="0" rtlCol="0" anchor="ctr"/>
           <a:lstStyle/>
           <a:p>
-            <a:pPr indent="0" marL="0">
+            <a:pPr marL="0" indent="0">
               <a:lnSpc>
                 <a:spcPct val="100000"/>
               </a:lnSpc>
@@ -6798,7 +7079,7 @@
           <a:bodyPr wrap="square" lIns="0" tIns="0" rIns="0" bIns="0" rtlCol="0" anchor="ctr"/>
           <a:lstStyle/>
           <a:p>
-            <a:pPr indent="0" marL="0">
+            <a:pPr marL="0" indent="0">
               <a:buNone/>
             </a:pPr>
             <a:r>
@@ -6842,13 +7123,20 @@
             <a:prstDash val="solid"/>
           </a:ln>
           <a:effectLst>
-            <a:outerShdw sx="100000" sy="100000" kx="0" ky="0" algn="bl" rotWithShape="0" blurRad="127000" dist="38100" dir="8100000">
+            <a:outerShdw blurRad="127000" dist="38100" dir="8100000" algn="bl" rotWithShape="0">
               <a:srgbClr val="000000">
                 <a:alpha val="10000"/>
               </a:srgbClr>
             </a:outerShdw>
           </a:effectLst>
         </p:spPr>
+        <p:txBody>
+          <a:bodyPr/>
+          <a:lstStyle/>
+          <a:p>
+            <a:endParaRPr lang="pl-PL"/>
+          </a:p>
+        </p:txBody>
       </p:sp>
       <p:sp>
         <p:nvSpPr>
@@ -6871,7 +7159,7 @@
           <a:bodyPr wrap="square" lIns="0" tIns="0" rIns="0" bIns="0" rtlCol="0" anchor="ctr"/>
           <a:lstStyle/>
           <a:p>
-            <a:pPr indent="0" marL="0">
+            <a:pPr marL="0" indent="0">
               <a:buNone/>
             </a:pPr>
             <a:r>
@@ -6985,13 +7273,20 @@
             <a:prstDash val="solid"/>
           </a:ln>
           <a:effectLst>
-            <a:outerShdw sx="100000" sy="100000" kx="0" ky="0" algn="bl" rotWithShape="0" blurRad="127000" dist="38100" dir="8100000">
+            <a:outerShdw blurRad="127000" dist="38100" dir="8100000" algn="bl" rotWithShape="0">
               <a:srgbClr val="000000">
                 <a:alpha val="10000"/>
               </a:srgbClr>
             </a:outerShdw>
           </a:effectLst>
         </p:spPr>
+        <p:txBody>
+          <a:bodyPr/>
+          <a:lstStyle/>
+          <a:p>
+            <a:endParaRPr lang="pl-PL"/>
+          </a:p>
+        </p:txBody>
       </p:sp>
       <p:sp>
         <p:nvSpPr>
@@ -7014,7 +7309,7 @@
           <a:bodyPr wrap="square" lIns="0" tIns="0" rIns="0" bIns="0" rtlCol="0" anchor="ctr"/>
           <a:lstStyle/>
           <a:p>
-            <a:pPr indent="0" marL="0">
+            <a:pPr marL="0" indent="0">
               <a:buNone/>
             </a:pPr>
             <a:r>
@@ -7123,7 +7418,7 @@
           <a:bodyPr wrap="square" lIns="0" tIns="0" rIns="0" bIns="0" rtlCol="0" anchor="ctr"/>
           <a:lstStyle/>
           <a:p>
-            <a:pPr indent="0" marL="0">
+            <a:pPr marL="0" indent="0">
               <a:buNone/>
             </a:pPr>
             <a:r>
@@ -7162,7 +7457,7 @@
           <a:bodyPr wrap="square" lIns="0" tIns="0" rIns="0" bIns="0" rtlCol="0" anchor="ctr"/>
           <a:lstStyle/>
           <a:p>
-            <a:pPr algn="r" indent="0" marL="0">
+            <a:pPr marL="0" indent="0" algn="r">
               <a:buNone/>
             </a:pPr>
             <a:r>
@@ -7481,4 +7776,319 @@
     </a:ext>
   </a:extLst>
 </a:theme>
+</file>
+
+<file path=ppt/theme/theme2.xml><?xml version="1.0" encoding="utf-8"?>
+<a:theme xmlns:a="http://schemas.openxmlformats.org/drawingml/2006/main" name="Motyw pakietu Office">
+  <a:themeElements>
+    <a:clrScheme name="Pakiet Office">
+      <a:dk1>
+        <a:sysClr val="windowText" lastClr="000000"/>
+      </a:dk1>
+      <a:lt1>
+        <a:sysClr val="window" lastClr="FFFFFF"/>
+      </a:lt1>
+      <a:dk2>
+        <a:srgbClr val="0E2841"/>
+      </a:dk2>
+      <a:lt2>
+        <a:srgbClr val="E8E8E8"/>
+      </a:lt2>
+      <a:accent1>
+        <a:srgbClr val="156082"/>
+      </a:accent1>
+      <a:accent2>
+        <a:srgbClr val="E97132"/>
+      </a:accent2>
+      <a:accent3>
+        <a:srgbClr val="196B24"/>
+      </a:accent3>
+      <a:accent4>
+        <a:srgbClr val="0F9ED5"/>
+      </a:accent4>
+      <a:accent5>
+        <a:srgbClr val="A02B93"/>
+      </a:accent5>
+      <a:accent6>
+        <a:srgbClr val="4EA72E"/>
+      </a:accent6>
+      <a:hlink>
+        <a:srgbClr val="467886"/>
+      </a:hlink>
+      <a:folHlink>
+        <a:srgbClr val="96607D"/>
+      </a:folHlink>
+    </a:clrScheme>
+    <a:fontScheme name="Pakiet Office">
+      <a:majorFont>
+        <a:latin typeface="Aptos Display" panose="02110004020202020204"/>
+        <a:ea typeface=""/>
+        <a:cs typeface=""/>
+        <a:font script="Jpan" typeface="游ゴシック Light"/>
+        <a:font script="Hang" typeface="맑은 고딕"/>
+        <a:font script="Hans" typeface="等线 Light"/>
+        <a:font script="Hant" typeface="新細明體"/>
+        <a:font script="Arab" typeface="Times New Roman"/>
+        <a:font script="Hebr" typeface="Times New Roman"/>
+        <a:font script="Thai" typeface="Angsana New"/>
+        <a:font script="Ethi" typeface="Nyala"/>
+        <a:font script="Beng" typeface="Vrinda"/>
+        <a:font script="Gujr" typeface="Shruti"/>
+        <a:font script="Khmr" typeface="MoolBoran"/>
+        <a:font script="Knda" typeface="Tunga"/>
+        <a:font script="Guru" typeface="Raavi"/>
+        <a:font script="Cans" typeface="Euphemia"/>
+        <a:font script="Cher" typeface="Plantagenet Cherokee"/>
+        <a:font script="Yiii" typeface="Microsoft Yi Baiti"/>
+        <a:font script="Tibt" typeface="Microsoft Himalaya"/>
+        <a:font script="Thaa" typeface="MV Boli"/>
+        <a:font script="Deva" typeface="Mangal"/>
+        <a:font script="Telu" typeface="Gautami"/>
+        <a:font script="Taml" typeface="Latha"/>
+        <a:font script="Syrc" typeface="Estrangelo Edessa"/>
+        <a:font script="Orya" typeface="Kalinga"/>
+        <a:font script="Mlym" typeface="Kartika"/>
+        <a:font script="Laoo" typeface="DokChampa"/>
+        <a:font script="Sinh" typeface="Iskoola Pota"/>
+        <a:font script="Mong" typeface="Mongolian Baiti"/>
+        <a:font script="Viet" typeface="Times New Roman"/>
+        <a:font script="Uigh" typeface="Microsoft Uighur"/>
+        <a:font script="Geor" typeface="Sylfaen"/>
+        <a:font script="Armn" typeface="Arial"/>
+        <a:font script="Bugi" typeface="Leelawadee UI"/>
+        <a:font script="Bopo" typeface="Microsoft JhengHei"/>
+        <a:font script="Java" typeface="Javanese Text"/>
+        <a:font script="Lisu" typeface="Segoe UI"/>
+        <a:font script="Mymr" typeface="Myanmar Text"/>
+        <a:font script="Nkoo" typeface="Ebrima"/>
+        <a:font script="Olck" typeface="Nirmala UI"/>
+        <a:font script="Osma" typeface="Ebrima"/>
+        <a:font script="Phag" typeface="Phagspa"/>
+        <a:font script="Syrn" typeface="Estrangelo Edessa"/>
+        <a:font script="Syrj" typeface="Estrangelo Edessa"/>
+        <a:font script="Syre" typeface="Estrangelo Edessa"/>
+        <a:font script="Sora" typeface="Nirmala UI"/>
+        <a:font script="Tale" typeface="Microsoft Tai Le"/>
+        <a:font script="Talu" typeface="Microsoft New Tai Lue"/>
+        <a:font script="Tfng" typeface="Ebrima"/>
+      </a:majorFont>
+      <a:minorFont>
+        <a:latin typeface="Aptos" panose="02110004020202020204"/>
+        <a:ea typeface=""/>
+        <a:cs typeface=""/>
+        <a:font script="Jpan" typeface="游ゴシック"/>
+        <a:font script="Hang" typeface="맑은 고딕"/>
+        <a:font script="Hans" typeface="等线"/>
+        <a:font script="Hant" typeface="新細明體"/>
+        <a:font script="Arab" typeface="Arial"/>
+        <a:font script="Hebr" typeface="Arial"/>
+        <a:font script="Thai" typeface="Cordia New"/>
+        <a:font script="Ethi" typeface="Nyala"/>
+        <a:font script="Beng" typeface="Vrinda"/>
+        <a:font script="Gujr" typeface="Shruti"/>
+        <a:font script="Khmr" typeface="DaunPenh"/>
+        <a:font script="Knda" typeface="Tunga"/>
+        <a:font script="Guru" typeface="Raavi"/>
+        <a:font script="Cans" typeface="Euphemia"/>
+        <a:font script="Cher" typeface="Plantagenet Cherokee"/>
+        <a:font script="Yiii" typeface="Microsoft Yi Baiti"/>
+        <a:font script="Tibt" typeface="Microsoft Himalaya"/>
+        <a:font script="Thaa" typeface="MV Boli"/>
+        <a:font script="Deva" typeface="Mangal"/>
+        <a:font script="Telu" typeface="Gautami"/>
+        <a:font script="Taml" typeface="Latha"/>
+        <a:font script="Syrc" typeface="Estrangelo Edessa"/>
+        <a:font script="Orya" typeface="Kalinga"/>
+        <a:font script="Mlym" typeface="Kartika"/>
+        <a:font script="Laoo" typeface="DokChampa"/>
+        <a:font script="Sinh" typeface="Iskoola Pota"/>
+        <a:font script="Mong" typeface="Mongolian Baiti"/>
+        <a:font script="Viet" typeface="Arial"/>
+        <a:font script="Uigh" typeface="Microsoft Uighur"/>
+        <a:font script="Geor" typeface="Sylfaen"/>
+        <a:font script="Armn" typeface="Arial"/>
+        <a:font script="Bugi" typeface="Leelawadee UI"/>
+        <a:font script="Bopo" typeface="Microsoft JhengHei"/>
+        <a:font script="Java" typeface="Javanese Text"/>
+        <a:font script="Lisu" typeface="Segoe UI"/>
+        <a:font script="Mymr" typeface="Myanmar Text"/>
+        <a:font script="Nkoo" typeface="Ebrima"/>
+        <a:font script="Olck" typeface="Nirmala UI"/>
+        <a:font script="Osma" typeface="Ebrima"/>
+        <a:font script="Phag" typeface="Phagspa"/>
+        <a:font script="Syrn" typeface="Estrangelo Edessa"/>
+        <a:font script="Syrj" typeface="Estrangelo Edessa"/>
+        <a:font script="Syre" typeface="Estrangelo Edessa"/>
+        <a:font script="Sora" typeface="Nirmala UI"/>
+        <a:font script="Tale" typeface="Microsoft Tai Le"/>
+        <a:font script="Talu" typeface="Microsoft New Tai Lue"/>
+        <a:font script="Tfng" typeface="Ebrima"/>
+      </a:minorFont>
+    </a:fontScheme>
+    <a:fmtScheme name="Pakiet Office">
+      <a:fillStyleLst>
+        <a:solidFill>
+          <a:schemeClr val="phClr"/>
+        </a:solidFill>
+        <a:gradFill rotWithShape="1">
+          <a:gsLst>
+            <a:gs pos="0">
+              <a:schemeClr val="phClr">
+                <a:lumMod val="110000"/>
+                <a:satMod val="105000"/>
+                <a:tint val="67000"/>
+              </a:schemeClr>
+            </a:gs>
+            <a:gs pos="50000">
+              <a:schemeClr val="phClr">
+                <a:lumMod val="105000"/>
+                <a:satMod val="103000"/>
+                <a:tint val="73000"/>
+              </a:schemeClr>
+            </a:gs>
+            <a:gs pos="100000">
+              <a:schemeClr val="phClr">
+                <a:lumMod val="105000"/>
+                <a:satMod val="109000"/>
+                <a:tint val="81000"/>
+              </a:schemeClr>
+            </a:gs>
+          </a:gsLst>
+          <a:lin ang="5400000" scaled="0"/>
+        </a:gradFill>
+        <a:gradFill rotWithShape="1">
+          <a:gsLst>
+            <a:gs pos="0">
+              <a:schemeClr val="phClr">
+                <a:satMod val="103000"/>
+                <a:lumMod val="102000"/>
+                <a:tint val="94000"/>
+              </a:schemeClr>
+            </a:gs>
+            <a:gs pos="50000">
+              <a:schemeClr val="phClr">
+                <a:satMod val="110000"/>
+                <a:lumMod val="100000"/>
+                <a:shade val="100000"/>
+              </a:schemeClr>
+            </a:gs>
+            <a:gs pos="100000">
+              <a:schemeClr val="phClr">
+                <a:lumMod val="99000"/>
+                <a:satMod val="120000"/>
+                <a:shade val="78000"/>
+              </a:schemeClr>
+            </a:gs>
+          </a:gsLst>
+          <a:lin ang="5400000" scaled="0"/>
+        </a:gradFill>
+      </a:fillStyleLst>
+      <a:lnStyleLst>
+        <a:ln w="12700" cap="flat" cmpd="sng" algn="ctr">
+          <a:solidFill>
+            <a:schemeClr val="phClr"/>
+          </a:solidFill>
+          <a:prstDash val="solid"/>
+          <a:miter lim="800000"/>
+        </a:ln>
+        <a:ln w="19050" cap="flat" cmpd="sng" algn="ctr">
+          <a:solidFill>
+            <a:schemeClr val="phClr"/>
+          </a:solidFill>
+          <a:prstDash val="solid"/>
+          <a:miter lim="800000"/>
+        </a:ln>
+        <a:ln w="25400" cap="flat" cmpd="sng" algn="ctr">
+          <a:solidFill>
+            <a:schemeClr val="phClr"/>
+          </a:solidFill>
+          <a:prstDash val="solid"/>
+          <a:miter lim="800000"/>
+        </a:ln>
+      </a:lnStyleLst>
+      <a:effectStyleLst>
+        <a:effectStyle>
+          <a:effectLst/>
+        </a:effectStyle>
+        <a:effectStyle>
+          <a:effectLst/>
+        </a:effectStyle>
+        <a:effectStyle>
+          <a:effectLst>
+            <a:outerShdw blurRad="57150" dist="19050" dir="5400000" algn="ctr" rotWithShape="0">
+              <a:srgbClr val="000000">
+                <a:alpha val="63000"/>
+              </a:srgbClr>
+            </a:outerShdw>
+          </a:effectLst>
+        </a:effectStyle>
+      </a:effectStyleLst>
+      <a:bgFillStyleLst>
+        <a:solidFill>
+          <a:schemeClr val="phClr"/>
+        </a:solidFill>
+        <a:solidFill>
+          <a:schemeClr val="phClr">
+            <a:tint val="95000"/>
+            <a:satMod val="170000"/>
+          </a:schemeClr>
+        </a:solidFill>
+        <a:gradFill rotWithShape="1">
+          <a:gsLst>
+            <a:gs pos="0">
+              <a:schemeClr val="phClr">
+                <a:tint val="93000"/>
+                <a:satMod val="150000"/>
+                <a:shade val="98000"/>
+                <a:lumMod val="102000"/>
+              </a:schemeClr>
+            </a:gs>
+            <a:gs pos="50000">
+              <a:schemeClr val="phClr">
+                <a:tint val="98000"/>
+                <a:satMod val="130000"/>
+                <a:shade val="90000"/>
+                <a:lumMod val="103000"/>
+              </a:schemeClr>
+            </a:gs>
+            <a:gs pos="100000">
+              <a:schemeClr val="phClr">
+                <a:shade val="63000"/>
+                <a:satMod val="120000"/>
+              </a:schemeClr>
+            </a:gs>
+          </a:gsLst>
+          <a:lin ang="5400000" scaled="0"/>
+        </a:gradFill>
+      </a:bgFillStyleLst>
+    </a:fmtScheme>
+  </a:themeElements>
+  <a:objectDefaults>
+    <a:lnDef>
+      <a:spPr/>
+      <a:bodyPr/>
+      <a:lstStyle/>
+      <a:style>
+        <a:lnRef idx="2">
+          <a:schemeClr val="accent1"/>
+        </a:lnRef>
+        <a:fillRef idx="0">
+          <a:schemeClr val="accent1"/>
+        </a:fillRef>
+        <a:effectRef idx="1">
+          <a:schemeClr val="accent1"/>
+        </a:effectRef>
+        <a:fontRef idx="minor">
+          <a:schemeClr val="tx1"/>
+        </a:fontRef>
+      </a:style>
+    </a:lnDef>
+  </a:objectDefaults>
+  <a:extraClrSchemeLst/>
+  <a:extLst>
+    <a:ext uri="{05A4C25C-085E-4340-85A3-A5531E510DB2}">
+      <thm15:themeFamily xmlns:thm15="http://schemas.microsoft.com/office/thememl/2012/main" name="Office Theme" id="{2E142A2C-CD16-42D6-873A-C26D2A0506FA}" vid="{1BDDFF52-6CD6-40A5-AB3C-68EB2F1E4D0A}"/>
+    </a:ext>
+  </a:extLst>
+</a:theme>
 </file>
</xml_diff>